<commit_message>
Update reports and slides with exact notebook metrics and Limitations section
</commit_message>
<xml_diff>
--- a/reports/presentation.pptx
+++ b/reports/presentation.pptx
@@ -3204,18 +3204,18 @@
           <a:p/>
           <a:p>
             <a:pPr>
-              <a:defRPr sz="1600"/>
+              <a:defRPr sz="1400"/>
             </a:pPr>
             <a:r>
-              <a:t>BiLSTM completely dominates across minority classes.</a:t>
+              <a:t>BiLSTM accurately maps minority classes.</a:t>
             </a:r>
           </a:p>
           <a:p>
             <a:pPr>
-              <a:defRPr sz="1600"/>
+              <a:defRPr sz="1400"/>
             </a:pPr>
             <a:r>
-              <a:t>Focal Loss eliminated the Subtype B collapse.</a:t>
+              <a:t>CNN and DNABERT collapsed entirely (52.22% Subtype B baseline).</a:t>
             </a:r>
           </a:p>
         </p:txBody>
@@ -3278,7 +3278,7 @@
           <a:lstStyle/>
           <a:p>
             <a:r>
-              <a:t>Methodology: Explainability (Saliency Map)</a:t>
+              <a:t>Error Analysis</a:t>
             </a:r>
           </a:p>
         </p:txBody>
@@ -3300,26 +3300,18 @@
           <a:p/>
           <a:p>
             <a:pPr>
-              <a:defRPr sz="1600"/>
+              <a:defRPr sz="2000"/>
             </a:pPr>
             <a:r>
-              <a:t>Ensured model wasn't relying on spurious correlations.</a:t>
+              <a:t>Causes: CNNs and DNABERT collapsed due to geographic imbalance.</a:t>
             </a:r>
           </a:p>
           <a:p>
             <a:pPr>
-              <a:defRPr sz="1600"/>
+              <a:defRPr sz="2000"/>
             </a:pPr>
             <a:r>
-              <a:t>Universal Saliency Map using Input-Gradient Attention.</a:t>
-            </a:r>
-          </a:p>
-          <a:p>
-            <a:pPr>
-              <a:defRPr sz="1600"/>
-            </a:pPr>
-            <a:r>
-              <a:t>Highlighting the exact nucleotide regions driving the BiLSTM's classifications.</a:t>
+              <a:t>Implications: Saliency Maps show BiLSTMs rely on conserved regions. When 'viral drift' mutates these domains, confidence drops.</a:t>
             </a:r>
           </a:p>
         </p:txBody>
@@ -3358,7 +3350,7 @@
           <a:lstStyle/>
           <a:p>
             <a:r>
-              <a:t>Error Analysis</a:t>
+              <a:t>Limitations &amp; Challenges</a:t>
             </a:r>
           </a:p>
         </p:txBody>
@@ -3380,26 +3372,26 @@
           <a:p/>
           <a:p>
             <a:pPr>
-              <a:defRPr sz="2200"/>
+              <a:defRPr sz="2000"/>
             </a:pPr>
             <a:r>
-              <a:t>Observed Trends: The 2% error margin occurred exclusively between closely related recombinant forms or hypermutations.</a:t>
+              <a:t>1. Extreme Geographical Imbalance: Hard for spatial models (CNN) to overcome.</a:t>
             </a:r>
           </a:p>
           <a:p>
             <a:pPr>
-              <a:defRPr sz="2200"/>
+              <a:defRPr sz="2000"/>
             </a:pPr>
             <a:r>
-              <a:t>Implications: The model heavily relies on rigid conserved regions.</a:t>
+              <a:t>2. Computational Limits: VRAM restricted DNABERT's ability to learn 3000bp sequences.</a:t>
             </a:r>
           </a:p>
           <a:p>
             <a:pPr>
-              <a:defRPr sz="2200"/>
+              <a:defRPr sz="2000"/>
             </a:pPr>
             <a:r>
-              <a:t>When 'viral drift' mutates these domains, the model's confidence drops, indicating a blur in rigid subtype boundaries.</a:t>
+              <a:t>3. Domain Gap: Human genome pre-training doesn't translate perfectly to viruses.</a:t>
             </a:r>
           </a:p>
         </p:txBody>
@@ -3460,31 +3452,23 @@
           <a:p/>
           <a:p>
             <a:pPr>
-              <a:defRPr sz="2200"/>
+              <a:defRPr sz="2000"/>
             </a:pPr>
             <a:r>
-              <a:t>A decoupled production deployment module.</a:t>
+              <a:t>Decoupled production deployment module.</a:t>
             </a:r>
           </a:p>
           <a:p>
             <a:pPr>
-              <a:defRPr sz="2200"/>
+              <a:defRPr sz="2000"/>
             </a:pPr>
             <a:r>
-              <a:t>Dynamically reads training histories.</a:t>
+              <a:t>Automatically loads the highest-performing architecture (BiLSTM).</a:t>
             </a:r>
           </a:p>
           <a:p>
             <a:pPr>
-              <a:defRPr sz="2200"/>
-            </a:pPr>
-            <a:r>
-              <a:t>Automatically identifies and loads the highest-performing architecture natively.</a:t>
-            </a:r>
-          </a:p>
-          <a:p>
-            <a:pPr>
-              <a:defRPr sz="2200"/>
+              <a:defRPr sz="2000"/>
             </a:pPr>
             <a:r>
               <a:t>Ready for real-time FASTA inference.</a:t>
@@ -3548,26 +3532,18 @@
           <a:p/>
           <a:p>
             <a:pPr>
-              <a:defRPr sz="2200"/>
+              <a:defRPr sz="2000"/>
             </a:pPr>
             <a:r>
-              <a:t>Conclusion: Alignment-free Deep Learning (BiLSTM) combined with Focal Loss achieves state-of-the-art 98% accuracy on raw HIV-1 pol sequences.</a:t>
+              <a:t>Conclusion: Alignment-free Deep Learning (BiLSTM) handles viral genomic imbalances far better than CNNs, achieving 94.73% accuracy.</a:t>
             </a:r>
           </a:p>
           <a:p>
             <a:pPr>
-              <a:defRPr sz="2200"/>
+              <a:defRPr sz="2000"/>
             </a:pPr>
             <a:r>
-              <a:t>Future Work 1: Expand to Circulating Recombinant Forms (CRFs).</a:t>
-            </a:r>
-          </a:p>
-          <a:p>
-            <a:pPr>
-              <a:defRPr sz="2200"/>
-            </a:pPr>
-            <a:r>
-              <a:t>Future Work 2: Wrap deployment module in a REST API for programmatic clinical use.</a:t>
+              <a:t>Future Work: Expand to Circulating Recombinant Forms (CRFs) and launch via FastAPI.</a:t>
             </a:r>
           </a:p>
         </p:txBody>
@@ -3628,42 +3604,42 @@
           <a:p/>
           <a:p>
             <a:pPr>
-              <a:defRPr sz="2200"/>
+              <a:defRPr sz="2000"/>
             </a:pPr>
             <a:r>
-              <a:t>Background: HIV-1 subtyping is critical for tracking epidemiological spread and drug resistance.</a:t>
+              <a:t>Background: HIV-1 subtyping is critical for tracking drug resistance.</a:t>
             </a:r>
           </a:p>
           <a:p>
             <a:pPr>
-              <a:defRPr sz="2200"/>
+              <a:defRPr sz="2000"/>
             </a:pPr>
             <a:r>
-              <a:t>Problem: Traditional alignment and k-mer methods struggle with hypermutations and computational cost.</a:t>
+              <a:t>Problem: Traditional MSA methods struggle with hypermutations.</a:t>
             </a:r>
           </a:p>
           <a:p>
             <a:pPr>
-              <a:defRPr sz="2200"/>
+              <a:defRPr sz="2000"/>
             </a:pPr>
             <a:r>
-              <a:t>Objective: Build an alignment-free Deep Learning pipeline for Subtypes A, B, C, D.</a:t>
+              <a:t>Objective: Alignment-free Deep Learning pipeline for Subtypes A, B, C, D.</a:t>
             </a:r>
           </a:p>
           <a:p>
             <a:pPr>
-              <a:defRPr sz="2200"/>
+              <a:defRPr sz="2000"/>
             </a:pPr>
             <a:r>
-              <a:t>Methods: 1D-CNN and BiLSTM networks using Focal Loss to combat severe class imbalance.</a:t>
+              <a:t>Methods: CNN and BiLSTM networks using Focal Loss.</a:t>
             </a:r>
           </a:p>
           <a:p>
             <a:pPr>
-              <a:defRPr sz="2200"/>
+              <a:defRPr sz="2000"/>
             </a:pPr>
             <a:r>
-              <a:t>Results: BiLSTM achieved 98% accuracy.</a:t>
+              <a:t>Results: BiLSTM achieved 94.73% accuracy, resisting majority-class collapse.</a:t>
             </a:r>
           </a:p>
         </p:txBody>
@@ -3702,7 +3678,7 @@
           <a:lstStyle/>
           <a:p>
             <a:r>
-              <a:t>Introduction / Background</a:t>
+              <a:t>The Dataset &amp; Geographical Bias</a:t>
             </a:r>
           </a:p>
         </p:txBody>
@@ -3724,114 +3700,26 @@
           <a:p/>
           <a:p>
             <a:pPr>
-              <a:defRPr sz="2200"/>
+              <a:defRPr sz="1400"/>
             </a:pPr>
             <a:r>
-              <a:t>The pol gene encodes targets for modern Antiretroviral Therapy (ART).</a:t>
+              <a:t>Data sourced from Los Alamos National Laboratory (LANL).</a:t>
             </a:r>
           </a:p>
           <a:p>
             <a:pPr>
-              <a:defRPr sz="2200"/>
+              <a:defRPr sz="1400"/>
             </a:pPr>
             <a:r>
-              <a:t>Subtype classification guides personalized medicine.</a:t>
+              <a:t>Severe Bias: Subtype B dominates North America &amp; Europe (52.2% of data).</a:t>
             </a:r>
           </a:p>
           <a:p>
             <a:pPr>
-              <a:defRPr sz="2200"/>
+              <a:defRPr sz="1400"/>
             </a:pPr>
             <a:r>
-              <a:t>Traditional bioinformatics heavily rely on Multiple Sequence Alignment (MSA).</a:t>
-            </a:r>
-          </a:p>
-          <a:p>
-            <a:pPr>
-              <a:defRPr sz="2200"/>
-            </a:pPr>
-            <a:r>
-              <a:t>Our approach completely eliminates MSA, feeding raw nucleotide strings into the network.</a:t>
-            </a:r>
-          </a:p>
-        </p:txBody>
-      </p:sp>
-    </p:spTree>
-  </p:cSld>
-  <p:clrMapOvr>
-    <a:masterClrMapping/>
-  </p:clrMapOvr>
-</p:sld>
-</file>
-
-<file path=ppt/slides/slide4.xml><?xml version="1.0" encoding="utf-8"?>
-<p:sld xmlns:a="http://schemas.openxmlformats.org/drawingml/2006/main" xmlns:p="http://schemas.openxmlformats.org/presentationml/2006/main" xmlns:r="http://schemas.openxmlformats.org/officeDocument/2006/relationships">
-  <p:cSld>
-    <p:spTree>
-      <p:nvGrpSpPr>
-        <p:cNvPr id="1" name=""/>
-        <p:cNvGrpSpPr/>
-        <p:nvPr/>
-      </p:nvGrpSpPr>
-      <p:grpSpPr/>
-      <p:sp>
-        <p:nvSpPr>
-          <p:cNvPr id="2" name="Title 1"/>
-          <p:cNvSpPr>
-            <a:spLocks noGrp="1"/>
-          </p:cNvSpPr>
-          <p:nvPr>
-            <p:ph type="title"/>
-          </p:nvPr>
-        </p:nvSpPr>
-        <p:spPr/>
-        <p:txBody>
-          <a:bodyPr/>
-          <a:lstStyle/>
-          <a:p>
-            <a:r>
-              <a:t>The Dataset &amp; The Imbalance Challenge</a:t>
-            </a:r>
-          </a:p>
-        </p:txBody>
-      </p:sp>
-      <p:sp>
-        <p:nvSpPr>
-          <p:cNvPr id="3" name="Content Placeholder 2"/>
-          <p:cNvSpPr>
-            <a:spLocks noGrp="1"/>
-          </p:cNvSpPr>
-          <p:nvPr>
-            <p:ph idx="1"/>
-          </p:nvPr>
-        </p:nvSpPr>
-        <p:spPr/>
-        <p:txBody>
-          <a:bodyPr/>
-          <a:lstStyle/>
-          <a:p/>
-          <a:p>
-            <a:pPr>
-              <a:defRPr sz="1600"/>
-            </a:pPr>
-            <a:r>
-              <a:t>Data sourced from Los Alamos National Laboratory (LANL).</a:t>
-            </a:r>
-          </a:p>
-          <a:p>
-            <a:pPr>
-              <a:defRPr sz="1600"/>
-            </a:pPr>
-            <a:r>
-              <a:t>Severe Geographical Bias: Subtype B dominates North America &amp; Europe.</a:t>
-            </a:r>
-          </a:p>
-          <a:p>
-            <a:pPr>
-              <a:defRPr sz="1600"/>
-            </a:pPr>
-            <a:r>
-              <a:t>A severe class imbalance risks model collapse (predicting B for everything).</a:t>
+              <a:t>Risk: Models inherently want to predict 'B' for everything to minimize loss.</a:t>
             </a:r>
           </a:p>
         </p:txBody>
@@ -3868,6 +3756,86 @@
 </p:sld>
 </file>
 
+<file path=ppt/slides/slide4.xml><?xml version="1.0" encoding="utf-8"?>
+<p:sld xmlns:a="http://schemas.openxmlformats.org/drawingml/2006/main" xmlns:p="http://schemas.openxmlformats.org/presentationml/2006/main" xmlns:r="http://schemas.openxmlformats.org/officeDocument/2006/relationships">
+  <p:cSld>
+    <p:spTree>
+      <p:nvGrpSpPr>
+        <p:cNvPr id="1" name=""/>
+        <p:cNvGrpSpPr/>
+        <p:nvPr/>
+      </p:nvGrpSpPr>
+      <p:grpSpPr/>
+      <p:sp>
+        <p:nvSpPr>
+          <p:cNvPr id="2" name="Title 1"/>
+          <p:cNvSpPr>
+            <a:spLocks noGrp="1"/>
+          </p:cNvSpPr>
+          <p:nvPr>
+            <p:ph type="title"/>
+          </p:nvPr>
+        </p:nvSpPr>
+        <p:spPr/>
+        <p:txBody>
+          <a:bodyPr/>
+          <a:lstStyle/>
+          <a:p>
+            <a:r>
+              <a:t>Methodology: Processing &amp; Encoding</a:t>
+            </a:r>
+          </a:p>
+        </p:txBody>
+      </p:sp>
+      <p:sp>
+        <p:nvSpPr>
+          <p:cNvPr id="3" name="Content Placeholder 2"/>
+          <p:cNvSpPr>
+            <a:spLocks noGrp="1"/>
+          </p:cNvSpPr>
+          <p:nvPr>
+            <p:ph idx="1"/>
+          </p:nvPr>
+        </p:nvSpPr>
+        <p:spPr/>
+        <p:txBody>
+          <a:bodyPr/>
+          <a:lstStyle/>
+          <a:p/>
+          <a:p>
+            <a:pPr>
+              <a:defRPr sz="2000"/>
+            </a:pPr>
+            <a:r>
+              <a:t>Alignment gaps ('-') completely stripped.</a:t>
+            </a:r>
+          </a:p>
+          <a:p>
+            <a:pPr>
+              <a:defRPr sz="2000"/>
+            </a:pPr>
+            <a:r>
+              <a:t>1. One-Hot Encoding: Used for MLP and 1D-CNN.</a:t>
+            </a:r>
+          </a:p>
+          <a:p>
+            <a:pPr>
+              <a:defRPr sz="2000"/>
+            </a:pPr>
+            <a:r>
+              <a:t>2. Label Embedding: Integers used for BiLSTM inputs.</a:t>
+            </a:r>
+          </a:p>
+        </p:txBody>
+      </p:sp>
+    </p:spTree>
+  </p:cSld>
+  <p:clrMapOvr>
+    <a:masterClrMapping/>
+  </p:clrMapOvr>
+</p:sld>
+</file>
+
 <file path=ppt/slides/slide5.xml><?xml version="1.0" encoding="utf-8"?>
 <p:sld xmlns:a="http://schemas.openxmlformats.org/drawingml/2006/main" xmlns:p="http://schemas.openxmlformats.org/presentationml/2006/main" xmlns:r="http://schemas.openxmlformats.org/officeDocument/2006/relationships">
   <p:cSld>
@@ -3894,7 +3862,7 @@
           <a:lstStyle/>
           <a:p>
             <a:r>
-              <a:t>Methodology: Processing &amp; Encoding</a:t>
+              <a:t>Methodology: Class Balancing</a:t>
             </a:r>
           </a:p>
         </p:txBody>
@@ -3916,42 +3884,26 @@
           <a:p/>
           <a:p>
             <a:pPr>
-              <a:defRPr sz="2200"/>
+              <a:defRPr sz="2000"/>
             </a:pPr>
             <a:r>
-              <a:t>Alignment gaps ('-') completely stripped from all sequences.</a:t>
+              <a:t>Standard categorical cross-entropy caused precision degradation.</a:t>
             </a:r>
           </a:p>
           <a:p>
             <a:pPr>
-              <a:defRPr sz="2200"/>
+              <a:defRPr sz="2000"/>
             </a:pPr>
             <a:r>
-              <a:t>Data was unified via padding/truncation for batched processing.</a:t>
+              <a:t>Implemented pure Focal Loss (Gamma=2.0).</a:t>
             </a:r>
           </a:p>
           <a:p>
             <a:pPr>
-              <a:defRPr sz="2200"/>
+              <a:defRPr sz="2000"/>
             </a:pPr>
             <a:r>
-              <a:t>Two Encodings Used:</a:t>
-            </a:r>
-          </a:p>
-          <a:p>
-            <a:pPr>
-              <a:defRPr sz="2200"/>
-            </a:pPr>
-            <a:r>
-              <a:t>1. One-Hot Encoding: Used for MLP and 1D-CNN (4 spatial channels).</a:t>
-            </a:r>
-          </a:p>
-          <a:p>
-            <a:pPr>
-              <a:defRPr sz="2200"/>
-            </a:pPr>
-            <a:r>
-              <a:t>2. Label Embedding: Integers used for BiLSTM sequence inputs.</a:t>
+              <a:t>Forces the gradient to focus heavily on hard-to-predict minority strains (A, C, D).</a:t>
             </a:r>
           </a:p>
         </p:txBody>
@@ -3990,7 +3942,7 @@
           <a:lstStyle/>
           <a:p>
             <a:r>
-              <a:t>Methodology: Class Balancing</a:t>
+              <a:t>Methodology: The Experiments</a:t>
             </a:r>
           </a:p>
         </p:txBody>
@@ -4012,34 +3964,26 @@
           <a:p/>
           <a:p>
             <a:pPr>
-              <a:defRPr sz="2200"/>
+              <a:defRPr sz="2000"/>
             </a:pPr>
             <a:r>
-              <a:t>Initial static 'class_weights' severely degraded precision.</a:t>
+              <a:t>Baseline MLP: Global Average Pooling. Looks at total nucleotide composition.</a:t>
             </a:r>
           </a:p>
           <a:p>
             <a:pPr>
-              <a:defRPr sz="2200"/>
+              <a:defRPr sz="2000"/>
             </a:pPr>
             <a:r>
-              <a:t>Solution: Pure Focal Loss (Gamma=2.0).</a:t>
+              <a:t>1D-CNN: Extracts localized spatial motifs (k-mers).</a:t>
             </a:r>
           </a:p>
           <a:p>
             <a:pPr>
-              <a:defRPr sz="2200"/>
+              <a:defRPr sz="2000"/>
             </a:pPr>
             <a:r>
-              <a:t>Dynamically down-weights easily classified majority sequences (Subtype B).</a:t>
-            </a:r>
-          </a:p>
-          <a:p>
-            <a:pPr>
-              <a:defRPr sz="2200"/>
-            </a:pPr>
-            <a:r>
-              <a:t>Forces the gradient to focus heavily on hard-to-predict minority strains (A, C, D).</a:t>
+              <a:t>BiLSTM: Bidirectional recurrent sequence processing. Captures long-range dependencies.</a:t>
             </a:r>
           </a:p>
         </p:txBody>
@@ -4078,7 +4022,7 @@
           <a:lstStyle/>
           <a:p>
             <a:r>
-              <a:t>Methodology: The Experiments</a:t>
+              <a:t>Methodology: Transfer Learning</a:t>
             </a:r>
           </a:p>
         </p:txBody>
@@ -4100,26 +4044,26 @@
           <a:p/>
           <a:p>
             <a:pPr>
-              <a:defRPr sz="2200"/>
+              <a:defRPr sz="2000"/>
             </a:pPr>
             <a:r>
-              <a:t>Baseline MLP: Global Average Pooling. Looked at total nucleotide composition.</a:t>
+              <a:t>Exploratory phase utilizing DNABERT.</a:t>
             </a:r>
           </a:p>
           <a:p>
             <a:pPr>
-              <a:defRPr sz="2200"/>
+              <a:defRPr sz="2000"/>
             </a:pPr>
             <a:r>
-              <a:t>1D-CNN: Convolutional filters extracting localized functional motifs (k-mers).</a:t>
+              <a:t>Pre-trained on the human genome via Masked Language Modeling.</a:t>
             </a:r>
           </a:p>
           <a:p>
             <a:pPr>
-              <a:defRPr sz="2200"/>
+              <a:defRPr sz="2000"/>
             </a:pPr>
             <a:r>
-              <a:t>BiLSTM: Bidirectional recurrent sequence processing. Captures long-range epistatic dependencies across the genome.</a:t>
+              <a:t>Classification head fine-tuned to test cross-domain transfer learning to viral genomes.</a:t>
             </a:r>
           </a:p>
         </p:txBody>
@@ -4158,7 +4102,7 @@
           <a:lstStyle/>
           <a:p>
             <a:r>
-              <a:t>Methodology: Transfer Learning (DNABERT)</a:t>
+              <a:t>Methodology: Explainability</a:t>
             </a:r>
           </a:p>
         </p:txBody>
@@ -4180,34 +4124,18 @@
           <a:p/>
           <a:p>
             <a:pPr>
-              <a:defRPr sz="2200"/>
+              <a:defRPr sz="1400"/>
             </a:pPr>
             <a:r>
-              <a:t>Exploratory phase utilizing DNABERT.</a:t>
+              <a:t>Universal Saliency Map using Input-Gradient Attention.</a:t>
             </a:r>
           </a:p>
           <a:p>
             <a:pPr>
-              <a:defRPr sz="2200"/>
+              <a:defRPr sz="1400"/>
             </a:pPr>
             <a:r>
-              <a:t>Transformer model pre-trained on the human genome via Masked Language Modeling.</a:t>
-            </a:r>
-          </a:p>
-          <a:p>
-            <a:pPr>
-              <a:defRPr sz="2200"/>
-            </a:pPr>
-            <a:r>
-              <a:t>Classification head fine-tuned to test cross-domain transfer learning to viral genomes.</a:t>
-            </a:r>
-          </a:p>
-          <a:p>
-            <a:pPr>
-              <a:defRPr sz="2200"/>
-            </a:pPr>
-            <a:r>
-              <a:t>Demonstrated the flexibility of the pipeline to handle Transformer architectures.</a:t>
+              <a:t>Highlights the exact nucleotide regions driving the BiLSTM's classifications.</a:t>
             </a:r>
           </a:p>
         </p:txBody>
@@ -4357,7 +4285,7 @@
                     <a:lstStyle/>
                     <a:p>
                       <a:r>
-                        <a:t>0.92</a:t>
+                        <a:t>0.6527</a:t>
                       </a:r>
                     </a:p>
                   </a:txBody>
@@ -4369,7 +4297,7 @@
                     <a:lstStyle/>
                     <a:p>
                       <a:r>
-                        <a:t>0.88</a:t>
+                        <a:t>0.5082</a:t>
                       </a:r>
                     </a:p>
                   </a:txBody>
@@ -4381,7 +4309,7 @@
                     <a:lstStyle/>
                     <a:p>
                       <a:r>
-                        <a:t>0.85</a:t>
+                        <a:t>0.7472</a:t>
                       </a:r>
                     </a:p>
                   </a:txBody>
@@ -4393,7 +4321,7 @@
                     <a:lstStyle/>
                     <a:p>
                       <a:r>
-                        <a:t>0.86</a:t>
+                        <a:t>0.5114</a:t>
                       </a:r>
                     </a:p>
                   </a:txBody>
@@ -4419,7 +4347,7 @@
                     <a:lstStyle/>
                     <a:p>
                       <a:r>
-                        <a:t>0.95</a:t>
+                        <a:t>0.5222</a:t>
                       </a:r>
                     </a:p>
                   </a:txBody>
@@ -4431,7 +4359,7 @@
                     <a:lstStyle/>
                     <a:p>
                       <a:r>
-                        <a:t>0.93</a:t>
+                        <a:t>0.1305</a:t>
                       </a:r>
                     </a:p>
                   </a:txBody>
@@ -4443,7 +4371,7 @@
                     <a:lstStyle/>
                     <a:p>
                       <a:r>
-                        <a:t>0.92</a:t>
+                        <a:t>0.2500</a:t>
                       </a:r>
                     </a:p>
                   </a:txBody>
@@ -4455,7 +4383,7 @@
                     <a:lstStyle/>
                     <a:p>
                       <a:r>
-                        <a:t>0.92</a:t>
+                        <a:t>0.1715</a:t>
                       </a:r>
                     </a:p>
                   </a:txBody>
@@ -4481,7 +4409,7 @@
                     <a:lstStyle/>
                     <a:p>
                       <a:r>
-                        <a:t>0.98</a:t>
+                        <a:t>0.9473</a:t>
                       </a:r>
                     </a:p>
                   </a:txBody>
@@ -4493,7 +4421,7 @@
                     <a:lstStyle/>
                     <a:p>
                       <a:r>
-                        <a:t>0.97</a:t>
+                        <a:t>0.6274</a:t>
                       </a:r>
                     </a:p>
                   </a:txBody>
@@ -4505,7 +4433,7 @@
                     <a:lstStyle/>
                     <a:p>
                       <a:r>
-                        <a:t>0.98</a:t>
+                        <a:t>0.6982</a:t>
                       </a:r>
                     </a:p>
                   </a:txBody>
@@ -4517,7 +4445,7 @@
                     <a:lstStyle/>
                     <a:p>
                       <a:r>
-                        <a:t>0.97</a:t>
+                        <a:t>0.6541</a:t>
                       </a:r>
                     </a:p>
                   </a:txBody>
@@ -4543,7 +4471,7 @@
                     <a:lstStyle/>
                     <a:p>
                       <a:r>
-                        <a:t>N/A</a:t>
+                        <a:t>0.5222</a:t>
                       </a:r>
                     </a:p>
                   </a:txBody>
@@ -4555,7 +4483,7 @@
                     <a:lstStyle/>
                     <a:p>
                       <a:r>
-                        <a:t>N/A</a:t>
+                        <a:t>0.1305</a:t>
                       </a:r>
                     </a:p>
                   </a:txBody>
@@ -4567,7 +4495,7 @@
                     <a:lstStyle/>
                     <a:p>
                       <a:r>
-                        <a:t>N/A</a:t>
+                        <a:t>0.2500</a:t>
                       </a:r>
                     </a:p>
                   </a:txBody>
@@ -4579,7 +4507,7 @@
                     <a:lstStyle/>
                     <a:p>
                       <a:r>
-                        <a:t>N/A</a:t>
+                        <a:t>0.1715</a:t>
                       </a:r>
                     </a:p>
                   </a:txBody>

</xml_diff>

<commit_message>
Inject architectural details and exact illustrations into reports
</commit_message>
<xml_diff>
--- a/reports/presentation.pptx
+++ b/reports/presentation.pptx
@@ -19,6 +19,7 @@
     <p:sldId id="267" r:id="rId18"/>
     <p:sldId id="268" r:id="rId19"/>
     <p:sldId id="269" r:id="rId20"/>
+    <p:sldId id="270" r:id="rId21"/>
   </p:sldIdLst>
   <p:sldSz cx="9144000" cy="6858000" type="screen4x3"/>
   <p:notesSz cx="6858000" cy="9144000"/>
@@ -3236,8 +3237,8 @@
         </p:blipFill>
         <p:spPr>
           <a:xfrm>
-            <a:off x="4114800" y="1371600"/>
-            <a:ext cx="4572000" cy="957081"/>
+            <a:off x="3657600" y="1371600"/>
+            <a:ext cx="5029200" cy="1052789"/>
           </a:xfrm>
           <a:prstGeom prst="rect">
             <a:avLst/>
@@ -3278,7 +3279,7 @@
           <a:lstStyle/>
           <a:p>
             <a:r>
-              <a:t>Error Analysis</a:t>
+              <a:t>Results: ROC Curves</a:t>
             </a:r>
           </a:p>
         </p:txBody>
@@ -3300,22 +3301,38 @@
           <a:p/>
           <a:p>
             <a:pPr>
-              <a:defRPr sz="2000"/>
+              <a:defRPr sz="1400"/>
             </a:pPr>
             <a:r>
-              <a:t>Causes: CNNs and DNABERT collapsed due to geographic imbalance.</a:t>
-            </a:r>
-          </a:p>
-          <a:p>
-            <a:pPr>
-              <a:defRPr sz="2000"/>
-            </a:pPr>
-            <a:r>
-              <a:t>Implications: Saliency Maps show BiLSTMs rely on conserved regions. When 'viral drift' mutates these domains, confidence drops.</a:t>
-            </a:r>
-          </a:p>
-        </p:txBody>
-      </p:sp>
+              <a:t>The Receiver Operating Characteristic confirms the BiLSTM's high true positive rate across all four classes.</a:t>
+            </a:r>
+          </a:p>
+        </p:txBody>
+      </p:sp>
+      <p:pic>
+        <p:nvPicPr>
+          <p:cNvPr id="4" name="Picture 3" descr="best_model_roc.png"/>
+          <p:cNvPicPr>
+            <a:picLocks noChangeAspect="1"/>
+          </p:cNvPicPr>
+          <p:nvPr/>
+        </p:nvPicPr>
+        <p:blipFill>
+          <a:blip r:embed="rId2"/>
+          <a:stretch>
+            <a:fillRect/>
+          </a:stretch>
+        </p:blipFill>
+        <p:spPr>
+          <a:xfrm>
+            <a:off x="4114800" y="1371600"/>
+            <a:ext cx="4572000" cy="3641580"/>
+          </a:xfrm>
+          <a:prstGeom prst="rect">
+            <a:avLst/>
+          </a:prstGeom>
+        </p:spPr>
+      </p:pic>
     </p:spTree>
   </p:cSld>
   <p:clrMapOvr>
@@ -3350,7 +3367,7 @@
           <a:lstStyle/>
           <a:p>
             <a:r>
-              <a:t>Limitations &amp; Challenges</a:t>
+              <a:t>Error Analysis</a:t>
             </a:r>
           </a:p>
         </p:txBody>
@@ -3375,7 +3392,7 @@
               <a:defRPr sz="2000"/>
             </a:pPr>
             <a:r>
-              <a:t>1. Extreme Geographical Imbalance: Hard for spatial models (CNN) to overcome.</a:t>
+              <a:t>Causes: CNNs and DNABERT collapsed due to geographic imbalance.</a:t>
             </a:r>
           </a:p>
           <a:p>
@@ -3383,15 +3400,7 @@
               <a:defRPr sz="2000"/>
             </a:pPr>
             <a:r>
-              <a:t>2. Computational Limits: VRAM restricted DNABERT's ability to learn 3000bp sequences.</a:t>
-            </a:r>
-          </a:p>
-          <a:p>
-            <a:pPr>
-              <a:defRPr sz="2000"/>
-            </a:pPr>
-            <a:r>
-              <a:t>3. Domain Gap: Human genome pre-training doesn't translate perfectly to viruses.</a:t>
+              <a:t>Implications: Saliency Maps show BiLSTMs rely on conserved regions. When 'viral drift' mutates these domains, confidence drops.</a:t>
             </a:r>
           </a:p>
         </p:txBody>
@@ -3430,7 +3439,7 @@
           <a:lstStyle/>
           <a:p>
             <a:r>
-              <a:t>Deployment Strategy</a:t>
+              <a:t>Limitations &amp; Challenges</a:t>
             </a:r>
           </a:p>
         </p:txBody>
@@ -3455,7 +3464,7 @@
               <a:defRPr sz="2000"/>
             </a:pPr>
             <a:r>
-              <a:t>Decoupled production deployment module.</a:t>
+              <a:t>1. Extreme Geographical Imbalance: Hard for spatial models (CNN) to overcome.</a:t>
             </a:r>
           </a:p>
           <a:p>
@@ -3463,7 +3472,7 @@
               <a:defRPr sz="2000"/>
             </a:pPr>
             <a:r>
-              <a:t>Automatically loads the highest-performing architecture (BiLSTM).</a:t>
+              <a:t>2. Computational Limits: VRAM restricted DNABERT's ability to learn 3000bp sequences.</a:t>
             </a:r>
           </a:p>
           <a:p>
@@ -3471,7 +3480,7 @@
               <a:defRPr sz="2000"/>
             </a:pPr>
             <a:r>
-              <a:t>Ready for real-time FASTA inference.</a:t>
+              <a:t>3. Domain Gap: Human genome pre-training doesn't translate perfectly to viruses.</a:t>
             </a:r>
           </a:p>
         </p:txBody>
@@ -3510,6 +3519,86 @@
           <a:lstStyle/>
           <a:p>
             <a:r>
+              <a:t>Deployment Strategy</a:t>
+            </a:r>
+          </a:p>
+        </p:txBody>
+      </p:sp>
+      <p:sp>
+        <p:nvSpPr>
+          <p:cNvPr id="3" name="Content Placeholder 2"/>
+          <p:cNvSpPr>
+            <a:spLocks noGrp="1"/>
+          </p:cNvSpPr>
+          <p:nvPr>
+            <p:ph idx="1"/>
+          </p:nvPr>
+        </p:nvSpPr>
+        <p:spPr/>
+        <p:txBody>
+          <a:bodyPr/>
+          <a:lstStyle/>
+          <a:p/>
+          <a:p>
+            <a:pPr>
+              <a:defRPr sz="2000"/>
+            </a:pPr>
+            <a:r>
+              <a:t>Decoupled production deployment module.</a:t>
+            </a:r>
+          </a:p>
+          <a:p>
+            <a:pPr>
+              <a:defRPr sz="2000"/>
+            </a:pPr>
+            <a:r>
+              <a:t>Automatically loads the highest-performing architecture (BiLSTM).</a:t>
+            </a:r>
+          </a:p>
+          <a:p>
+            <a:pPr>
+              <a:defRPr sz="2000"/>
+            </a:pPr>
+            <a:r>
+              <a:t>Ready for real-time FASTA inference.</a:t>
+            </a:r>
+          </a:p>
+        </p:txBody>
+      </p:sp>
+    </p:spTree>
+  </p:cSld>
+  <p:clrMapOvr>
+    <a:masterClrMapping/>
+  </p:clrMapOvr>
+</p:sld>
+</file>
+
+<file path=ppt/slides/slide15.xml><?xml version="1.0" encoding="utf-8"?>
+<p:sld xmlns:a="http://schemas.openxmlformats.org/drawingml/2006/main" xmlns:p="http://schemas.openxmlformats.org/presentationml/2006/main" xmlns:r="http://schemas.openxmlformats.org/officeDocument/2006/relationships">
+  <p:cSld>
+    <p:spTree>
+      <p:nvGrpSpPr>
+        <p:cNvPr id="1" name=""/>
+        <p:cNvGrpSpPr/>
+        <p:nvPr/>
+      </p:nvGrpSpPr>
+      <p:grpSpPr/>
+      <p:sp>
+        <p:nvSpPr>
+          <p:cNvPr id="2" name="Title 1"/>
+          <p:cNvSpPr>
+            <a:spLocks noGrp="1"/>
+          </p:cNvSpPr>
+          <p:nvPr>
+            <p:ph type="title"/>
+          </p:nvPr>
+        </p:nvSpPr>
+        <p:spPr/>
+        <p:txBody>
+          <a:bodyPr/>
+          <a:lstStyle/>
+          <a:p>
+            <a:r>
               <a:t>Conclusion &amp; Future Work</a:t>
             </a:r>
           </a:p>
@@ -3719,7 +3808,111 @@
               <a:defRPr sz="1400"/>
             </a:pPr>
             <a:r>
-              <a:t>Risk: Models inherently want to predict 'B' for everything to minimize loss.</a:t>
+              <a:t>Sequence Length Variability: Shown in the plot, padded to 3000bp.</a:t>
+            </a:r>
+          </a:p>
+        </p:txBody>
+      </p:sp>
+      <p:pic>
+        <p:nvPicPr>
+          <p:cNvPr id="4" name="Picture 3" descr="sequence_lengths.png"/>
+          <p:cNvPicPr>
+            <a:picLocks noChangeAspect="1"/>
+          </p:cNvPicPr>
+          <p:nvPr/>
+        </p:nvPicPr>
+        <p:blipFill>
+          <a:blip r:embed="rId2"/>
+          <a:stretch>
+            <a:fillRect/>
+          </a:stretch>
+        </p:blipFill>
+        <p:spPr>
+          <a:xfrm>
+            <a:off x="4114800" y="1371600"/>
+            <a:ext cx="4572000" cy="2498981"/>
+          </a:xfrm>
+          <a:prstGeom prst="rect">
+            <a:avLst/>
+          </a:prstGeom>
+        </p:spPr>
+      </p:pic>
+    </p:spTree>
+  </p:cSld>
+  <p:clrMapOvr>
+    <a:masterClrMapping/>
+  </p:clrMapOvr>
+</p:sld>
+</file>
+
+<file path=ppt/slides/slide4.xml><?xml version="1.0" encoding="utf-8"?>
+<p:sld xmlns:a="http://schemas.openxmlformats.org/drawingml/2006/main" xmlns:p="http://schemas.openxmlformats.org/presentationml/2006/main" xmlns:r="http://schemas.openxmlformats.org/officeDocument/2006/relationships">
+  <p:cSld>
+    <p:spTree>
+      <p:nvGrpSpPr>
+        <p:cNvPr id="1" name=""/>
+        <p:cNvGrpSpPr/>
+        <p:nvPr/>
+      </p:nvGrpSpPr>
+      <p:grpSpPr/>
+      <p:sp>
+        <p:nvSpPr>
+          <p:cNvPr id="2" name="Title 1"/>
+          <p:cNvSpPr>
+            <a:spLocks noGrp="1"/>
+          </p:cNvSpPr>
+          <p:nvPr>
+            <p:ph type="title"/>
+          </p:nvPr>
+        </p:nvSpPr>
+        <p:spPr/>
+        <p:txBody>
+          <a:bodyPr/>
+          <a:lstStyle/>
+          <a:p>
+            <a:r>
+              <a:t>Methodology: Processing &amp; Encoding</a:t>
+            </a:r>
+          </a:p>
+        </p:txBody>
+      </p:sp>
+      <p:sp>
+        <p:nvSpPr>
+          <p:cNvPr id="3" name="Content Placeholder 2"/>
+          <p:cNvSpPr>
+            <a:spLocks noGrp="1"/>
+          </p:cNvSpPr>
+          <p:nvPr>
+            <p:ph idx="1"/>
+          </p:nvPr>
+        </p:nvSpPr>
+        <p:spPr/>
+        <p:txBody>
+          <a:bodyPr/>
+          <a:lstStyle/>
+          <a:p/>
+          <a:p>
+            <a:pPr>
+              <a:defRPr sz="1400"/>
+            </a:pPr>
+            <a:r>
+              <a:t>Alignment gaps ('-') completely stripped.</a:t>
+            </a:r>
+          </a:p>
+          <a:p>
+            <a:pPr>
+              <a:defRPr sz="1400"/>
+            </a:pPr>
+            <a:r>
+              <a:t>1. One-Hot Encoding: Used for MLP and 1D-CNN.</a:t>
+            </a:r>
+          </a:p>
+          <a:p>
+            <a:pPr>
+              <a:defRPr sz="1400"/>
+            </a:pPr>
+            <a:r>
+              <a:t>2. Label Embedding: Integers used for BiLSTM inputs.</a:t>
             </a:r>
           </a:p>
         </p:txBody>
@@ -3756,86 +3949,6 @@
 </p:sld>
 </file>
 
-<file path=ppt/slides/slide4.xml><?xml version="1.0" encoding="utf-8"?>
-<p:sld xmlns:a="http://schemas.openxmlformats.org/drawingml/2006/main" xmlns:p="http://schemas.openxmlformats.org/presentationml/2006/main" xmlns:r="http://schemas.openxmlformats.org/officeDocument/2006/relationships">
-  <p:cSld>
-    <p:spTree>
-      <p:nvGrpSpPr>
-        <p:cNvPr id="1" name=""/>
-        <p:cNvGrpSpPr/>
-        <p:nvPr/>
-      </p:nvGrpSpPr>
-      <p:grpSpPr/>
-      <p:sp>
-        <p:nvSpPr>
-          <p:cNvPr id="2" name="Title 1"/>
-          <p:cNvSpPr>
-            <a:spLocks noGrp="1"/>
-          </p:cNvSpPr>
-          <p:nvPr>
-            <p:ph type="title"/>
-          </p:nvPr>
-        </p:nvSpPr>
-        <p:spPr/>
-        <p:txBody>
-          <a:bodyPr/>
-          <a:lstStyle/>
-          <a:p>
-            <a:r>
-              <a:t>Methodology: Processing &amp; Encoding</a:t>
-            </a:r>
-          </a:p>
-        </p:txBody>
-      </p:sp>
-      <p:sp>
-        <p:nvSpPr>
-          <p:cNvPr id="3" name="Content Placeholder 2"/>
-          <p:cNvSpPr>
-            <a:spLocks noGrp="1"/>
-          </p:cNvSpPr>
-          <p:nvPr>
-            <p:ph idx="1"/>
-          </p:nvPr>
-        </p:nvSpPr>
-        <p:spPr/>
-        <p:txBody>
-          <a:bodyPr/>
-          <a:lstStyle/>
-          <a:p/>
-          <a:p>
-            <a:pPr>
-              <a:defRPr sz="2000"/>
-            </a:pPr>
-            <a:r>
-              <a:t>Alignment gaps ('-') completely stripped.</a:t>
-            </a:r>
-          </a:p>
-          <a:p>
-            <a:pPr>
-              <a:defRPr sz="2000"/>
-            </a:pPr>
-            <a:r>
-              <a:t>1. One-Hot Encoding: Used for MLP and 1D-CNN.</a:t>
-            </a:r>
-          </a:p>
-          <a:p>
-            <a:pPr>
-              <a:defRPr sz="2000"/>
-            </a:pPr>
-            <a:r>
-              <a:t>2. Label Embedding: Integers used for BiLSTM inputs.</a:t>
-            </a:r>
-          </a:p>
-        </p:txBody>
-      </p:sp>
-    </p:spTree>
-  </p:cSld>
-  <p:clrMapOvr>
-    <a:masterClrMapping/>
-  </p:clrMapOvr>
-</p:sld>
-</file>
-
 <file path=ppt/slides/slide5.xml><?xml version="1.0" encoding="utf-8"?>
 <p:sld xmlns:a="http://schemas.openxmlformats.org/drawingml/2006/main" xmlns:p="http://schemas.openxmlformats.org/presentationml/2006/main" xmlns:r="http://schemas.openxmlformats.org/officeDocument/2006/relationships">
   <p:cSld>
@@ -3942,7 +4055,7 @@
           <a:lstStyle/>
           <a:p>
             <a:r>
-              <a:t>Methodology: The Experiments</a:t>
+              <a:t>Methodology: Architectures</a:t>
             </a:r>
           </a:p>
         </p:txBody>
@@ -3967,7 +4080,7 @@
               <a:defRPr sz="2000"/>
             </a:pPr>
             <a:r>
-              <a:t>Baseline MLP: Global Average Pooling. Looks at total nucleotide composition.</a:t>
+              <a:t>1. Baseline MLP (73.8k Params): GlobalAvgPool -&gt; Dense(16) -&gt; Classifier.</a:t>
             </a:r>
           </a:p>
           <a:p>
@@ -3975,7 +4088,7 @@
               <a:defRPr sz="2000"/>
             </a:pPr>
             <a:r>
-              <a:t>1D-CNN: Extracts localized spatial motifs (k-mers).</a:t>
+              <a:t>2. 1D-CNN (200k Params): 4 Conv1D layers (filters: 32 to 128) alternating with MaxPool &amp; Dropout (0.5).</a:t>
             </a:r>
           </a:p>
           <a:p>
@@ -3983,7 +4096,7 @@
               <a:defRPr sz="2000"/>
             </a:pPr>
             <a:r>
-              <a:t>BiLSTM: Bidirectional recurrent sequence processing. Captures long-range dependencies.</a:t>
+              <a:t>3. BiLSTM (2.1M Params): 128-dim Embedding -&gt; 2-layer Bidirectional LSTM (256 hidden) -&gt; Dense(128).</a:t>
             </a:r>
           </a:p>
         </p:txBody>
@@ -4044,7 +4157,7 @@
           <a:p/>
           <a:p>
             <a:pPr>
-              <a:defRPr sz="2000"/>
+              <a:defRPr sz="1400"/>
             </a:pPr>
             <a:r>
               <a:t>Exploratory phase utilizing DNABERT.</a:t>
@@ -4052,7 +4165,7 @@
           </a:p>
           <a:p>
             <a:pPr>
-              <a:defRPr sz="2000"/>
+              <a:defRPr sz="1400"/>
             </a:pPr>
             <a:r>
               <a:t>Pre-trained on the human genome via Masked Language Modeling.</a:t>
@@ -4060,7 +4173,7 @@
           </a:p>
           <a:p>
             <a:pPr>
-              <a:defRPr sz="2000"/>
+              <a:defRPr sz="1400"/>
             </a:pPr>
             <a:r>
               <a:t>Classification head fine-tuned to test cross-domain transfer learning to viral genomes.</a:t>
@@ -4068,6 +4181,30 @@
           </a:p>
         </p:txBody>
       </p:sp>
+      <p:pic>
+        <p:nvPicPr>
+          <p:cNvPr id="4" name="Picture 3" descr="dnabert_training_curves.png"/>
+          <p:cNvPicPr>
+            <a:picLocks noChangeAspect="1"/>
+          </p:cNvPicPr>
+          <p:nvPr/>
+        </p:nvPicPr>
+        <p:blipFill>
+          <a:blip r:embed="rId2"/>
+          <a:stretch>
+            <a:fillRect/>
+          </a:stretch>
+        </p:blipFill>
+        <p:spPr>
+          <a:xfrm>
+            <a:off x="4114800" y="1371600"/>
+            <a:ext cx="4572000" cy="1524000"/>
+          </a:xfrm>
+          <a:prstGeom prst="rect">
+            <a:avLst/>
+          </a:prstGeom>
+        </p:spPr>
+      </p:pic>
     </p:spTree>
   </p:cSld>
   <p:clrMapOvr>

</xml_diff>

<commit_message>
Consolidate presentation and report files to original names
</commit_message>
<xml_diff>
--- a/reports/presentation.pptx
+++ b/reports/presentation.pptx
@@ -3671,7 +3671,7 @@
           <a:lstStyle/>
           <a:p>
             <a:r>
-              <a:t>Abstract &amp; Objective</a:t>
+              <a:t>Abstract &amp; Overview</a:t>
             </a:r>
           </a:p>
         </p:txBody>
@@ -3696,7 +3696,7 @@
               <a:defRPr sz="2000"/>
             </a:pPr>
             <a:r>
-              <a:t>Background: HIV-1 subtyping is critical for tracking drug resistance.</a:t>
+              <a:t>Background: HIV-1 subtyping is essential for guiding antiretroviral therapy and tracking epidemiological spread.</a:t>
             </a:r>
           </a:p>
           <a:p>
@@ -3704,7 +3704,7 @@
               <a:defRPr sz="2000"/>
             </a:pPr>
             <a:r>
-              <a:t>Problem: Traditional MSA methods struggle with hypermutations.</a:t>
+              <a:t>Previous Work: Existing tools heavily rely on computationally expensive Multiple Sequence Alignment (MSA) or k-mer counting.</a:t>
             </a:r>
           </a:p>
           <a:p>
@@ -3712,7 +3712,7 @@
               <a:defRPr sz="2000"/>
             </a:pPr>
             <a:r>
-              <a:t>Objective: Alignment-free Deep Learning pipeline for Subtypes A, B, C, D.</a:t>
+              <a:t>Problem Statement: MSA struggles with hypermutations, and genomic databases suffer from severe geographical class imbalance.</a:t>
             </a:r>
           </a:p>
           <a:p>
@@ -3720,7 +3720,7 @@
               <a:defRPr sz="2000"/>
             </a:pPr>
             <a:r>
-              <a:t>Methods: CNN and BiLSTM networks using Focal Loss.</a:t>
+              <a:t>Objective: To develop an automated, alignment-free Deep Learning classifier to categorize raw nucleotide sequences into Subtypes A, B, C, and D.</a:t>
             </a:r>
           </a:p>
           <a:p>
@@ -3728,7 +3728,7 @@
               <a:defRPr sz="2000"/>
             </a:pPr>
             <a:r>
-              <a:t>Results: BiLSTM achieved 94.73% accuracy, resisting majority-class collapse.</a:t>
+              <a:t>Significance: Eliminating the MSA bottleneck enables faster, more scalable, and highly accurate subtyping for clinical deployment.</a:t>
             </a:r>
           </a:p>
         </p:txBody>

</xml_diff>

<commit_message>
Update dataset slide with Kameris extraction details and single distribution bar graph
</commit_message>
<xml_diff>
--- a/reports/presentation.pptx
+++ b/reports/presentation.pptx
@@ -3767,7 +3767,7 @@
           <a:lstStyle/>
           <a:p>
             <a:r>
-              <a:t>The Dataset &amp; Geographical Bias</a:t>
+              <a:t>Data Acquisition (Kameris Experiment)</a:t>
             </a:r>
           </a:p>
         </p:txBody>
@@ -3792,7 +3792,7 @@
               <a:defRPr sz="1400"/>
             </a:pPr>
             <a:r>
-              <a:t>Data sourced from Los Alamos National Laboratory (LANL).</a:t>
+              <a:t>Data was acquired by parsing 9,270 HIV-1 pol gene accessions utilized in the Kameris et al. experiment.</a:t>
             </a:r>
           </a:p>
           <a:p>
@@ -3800,7 +3800,7 @@
               <a:defRPr sz="1400"/>
             </a:pPr>
             <a:r>
-              <a:t>Severe Bias: Subtype B dominates North America &amp; Europe (52.2% of data).</a:t>
+              <a:t>A JSON file was pulled from the Kameris GitHub repository to extract specific LANL sequence IDs.</a:t>
             </a:r>
           </a:p>
           <a:p>
@@ -3808,14 +3808,30 @@
               <a:defRPr sz="1400"/>
             </a:pPr>
             <a:r>
-              <a:t>Sequence Length Variability: Shown in the plot, padded to 3000bp.</a:t>
+              <a:t>These IDs were fed into the LANL HIV Sequence Database to batch download the raw FASTA sequences.</a:t>
+            </a:r>
+          </a:p>
+          <a:p>
+            <a:pPr>
+              <a:defRPr sz="1400"/>
+            </a:pPr>
+            <a:r>
+              <a:t>Sequences were then strictly filtered to our 4 target classes: Subtypes A, B, C, and D.</a:t>
+            </a:r>
+          </a:p>
+          <a:p>
+            <a:pPr>
+              <a:defRPr sz="1400"/>
+            </a:pPr>
+            <a:r>
+              <a:t>Severe Bias: Subtype B heavily dominates the final dataset (52.2%).</a:t>
             </a:r>
           </a:p>
         </p:txBody>
       </p:sp>
       <p:pic>
         <p:nvPicPr>
-          <p:cNvPr id="4" name="Picture 3" descr="sequence_lengths.png"/>
+          <p:cNvPr id="4" name="Picture 3" descr="subtype_distribution.png"/>
           <p:cNvPicPr>
             <a:picLocks noChangeAspect="1"/>
           </p:cNvPicPr>
@@ -3830,7 +3846,7 @@
         <p:spPr>
           <a:xfrm>
             <a:off x="4114800" y="1371600"/>
-            <a:ext cx="4572000" cy="2498981"/>
+            <a:ext cx="4572000" cy="1766619"/>
           </a:xfrm>
           <a:prstGeom prst="rect">
             <a:avLst/>

</xml_diff>

<commit_message>
Update methodology to a custom two-column slide for processing and class balance
</commit_message>
<xml_diff>
--- a/reports/presentation.pptx
+++ b/reports/presentation.pptx
@@ -19,7 +19,6 @@
     <p:sldId id="267" r:id="rId18"/>
     <p:sldId id="268" r:id="rId19"/>
     <p:sldId id="269" r:id="rId20"/>
-    <p:sldId id="270" r:id="rId21"/>
   </p:sldIdLst>
   <p:sldSz cx="9144000" cy="6858000" type="screen4x3"/>
   <p:notesSz cx="6858000" cy="9144000"/>
@@ -3183,102 +3182,6 @@
           <a:lstStyle/>
           <a:p>
             <a:r>
-              <a:t>Results: Confusion Matrices</a:t>
-            </a:r>
-          </a:p>
-        </p:txBody>
-      </p:sp>
-      <p:sp>
-        <p:nvSpPr>
-          <p:cNvPr id="3" name="Content Placeholder 2"/>
-          <p:cNvSpPr>
-            <a:spLocks noGrp="1"/>
-          </p:cNvSpPr>
-          <p:nvPr>
-            <p:ph idx="1"/>
-          </p:nvPr>
-        </p:nvSpPr>
-        <p:spPr/>
-        <p:txBody>
-          <a:bodyPr/>
-          <a:lstStyle/>
-          <a:p/>
-          <a:p>
-            <a:pPr>
-              <a:defRPr sz="1400"/>
-            </a:pPr>
-            <a:r>
-              <a:t>BiLSTM accurately maps minority classes.</a:t>
-            </a:r>
-          </a:p>
-          <a:p>
-            <a:pPr>
-              <a:defRPr sz="1400"/>
-            </a:pPr>
-            <a:r>
-              <a:t>CNN and DNABERT collapsed entirely (52.22% Subtype B baseline).</a:t>
-            </a:r>
-          </a:p>
-        </p:txBody>
-      </p:sp>
-      <p:pic>
-        <p:nvPicPr>
-          <p:cNvPr id="4" name="Picture 3" descr="all_confusion_matrices.png"/>
-          <p:cNvPicPr>
-            <a:picLocks noChangeAspect="1"/>
-          </p:cNvPicPr>
-          <p:nvPr/>
-        </p:nvPicPr>
-        <p:blipFill>
-          <a:blip r:embed="rId2"/>
-          <a:stretch>
-            <a:fillRect/>
-          </a:stretch>
-        </p:blipFill>
-        <p:spPr>
-          <a:xfrm>
-            <a:off x="3657600" y="1371600"/>
-            <a:ext cx="5029200" cy="1052789"/>
-          </a:xfrm>
-          <a:prstGeom prst="rect">
-            <a:avLst/>
-          </a:prstGeom>
-        </p:spPr>
-      </p:pic>
-    </p:spTree>
-  </p:cSld>
-  <p:clrMapOvr>
-    <a:masterClrMapping/>
-  </p:clrMapOvr>
-</p:sld>
-</file>
-
-<file path=ppt/slides/slide11.xml><?xml version="1.0" encoding="utf-8"?>
-<p:sld xmlns:a="http://schemas.openxmlformats.org/drawingml/2006/main" xmlns:p="http://schemas.openxmlformats.org/presentationml/2006/main" xmlns:r="http://schemas.openxmlformats.org/officeDocument/2006/relationships">
-  <p:cSld>
-    <p:spTree>
-      <p:nvGrpSpPr>
-        <p:cNvPr id="1" name=""/>
-        <p:cNvGrpSpPr/>
-        <p:nvPr/>
-      </p:nvGrpSpPr>
-      <p:grpSpPr/>
-      <p:sp>
-        <p:nvSpPr>
-          <p:cNvPr id="2" name="Title 1"/>
-          <p:cNvSpPr>
-            <a:spLocks noGrp="1"/>
-          </p:cNvSpPr>
-          <p:nvPr>
-            <p:ph type="title"/>
-          </p:nvPr>
-        </p:nvSpPr>
-        <p:spPr/>
-        <p:txBody>
-          <a:bodyPr/>
-          <a:lstStyle/>
-          <a:p>
-            <a:r>
               <a:t>Results: ROC Curves</a:t>
             </a:r>
           </a:p>
@@ -3341,6 +3244,78 @@
 </p:sld>
 </file>
 
+<file path=ppt/slides/slide11.xml><?xml version="1.0" encoding="utf-8"?>
+<p:sld xmlns:a="http://schemas.openxmlformats.org/drawingml/2006/main" xmlns:p="http://schemas.openxmlformats.org/presentationml/2006/main" xmlns:r="http://schemas.openxmlformats.org/officeDocument/2006/relationships">
+  <p:cSld>
+    <p:spTree>
+      <p:nvGrpSpPr>
+        <p:cNvPr id="1" name=""/>
+        <p:cNvGrpSpPr/>
+        <p:nvPr/>
+      </p:nvGrpSpPr>
+      <p:grpSpPr/>
+      <p:sp>
+        <p:nvSpPr>
+          <p:cNvPr id="2" name="Title 1"/>
+          <p:cNvSpPr>
+            <a:spLocks noGrp="1"/>
+          </p:cNvSpPr>
+          <p:nvPr>
+            <p:ph type="title"/>
+          </p:nvPr>
+        </p:nvSpPr>
+        <p:spPr/>
+        <p:txBody>
+          <a:bodyPr/>
+          <a:lstStyle/>
+          <a:p>
+            <a:r>
+              <a:t>Error Analysis</a:t>
+            </a:r>
+          </a:p>
+        </p:txBody>
+      </p:sp>
+      <p:sp>
+        <p:nvSpPr>
+          <p:cNvPr id="3" name="Content Placeholder 2"/>
+          <p:cNvSpPr>
+            <a:spLocks noGrp="1"/>
+          </p:cNvSpPr>
+          <p:nvPr>
+            <p:ph idx="1"/>
+          </p:nvPr>
+        </p:nvSpPr>
+        <p:spPr/>
+        <p:txBody>
+          <a:bodyPr/>
+          <a:lstStyle/>
+          <a:p/>
+          <a:p>
+            <a:pPr>
+              <a:defRPr sz="2000"/>
+            </a:pPr>
+            <a:r>
+              <a:t>Causes: CNNs and DNABERT collapsed due to geographic imbalance.</a:t>
+            </a:r>
+          </a:p>
+          <a:p>
+            <a:pPr>
+              <a:defRPr sz="2000"/>
+            </a:pPr>
+            <a:r>
+              <a:t>Implications: Saliency Maps show BiLSTMs rely on conserved regions. When 'viral drift' mutates these domains, confidence drops.</a:t>
+            </a:r>
+          </a:p>
+        </p:txBody>
+      </p:sp>
+    </p:spTree>
+  </p:cSld>
+  <p:clrMapOvr>
+    <a:masterClrMapping/>
+  </p:clrMapOvr>
+</p:sld>
+</file>
+
 <file path=ppt/slides/slide12.xml><?xml version="1.0" encoding="utf-8"?>
 <p:sld xmlns:a="http://schemas.openxmlformats.org/drawingml/2006/main" xmlns:p="http://schemas.openxmlformats.org/presentationml/2006/main" xmlns:r="http://schemas.openxmlformats.org/officeDocument/2006/relationships">
   <p:cSld>
@@ -3367,7 +3342,7 @@
           <a:lstStyle/>
           <a:p>
             <a:r>
-              <a:t>Error Analysis</a:t>
+              <a:t>Limitations &amp; Challenges</a:t>
             </a:r>
           </a:p>
         </p:txBody>
@@ -3392,7 +3367,7 @@
               <a:defRPr sz="2000"/>
             </a:pPr>
             <a:r>
-              <a:t>Causes: CNNs and DNABERT collapsed due to geographic imbalance.</a:t>
+              <a:t>1. Extreme Geographical Imbalance: Hard for spatial models (CNN) to overcome.</a:t>
             </a:r>
           </a:p>
           <a:p>
@@ -3400,7 +3375,15 @@
               <a:defRPr sz="2000"/>
             </a:pPr>
             <a:r>
-              <a:t>Implications: Saliency Maps show BiLSTMs rely on conserved regions. When 'viral drift' mutates these domains, confidence drops.</a:t>
+              <a:t>2. Computational Limits: VRAM restricted DNABERT's ability to learn 3000bp sequences.</a:t>
+            </a:r>
+          </a:p>
+          <a:p>
+            <a:pPr>
+              <a:defRPr sz="2000"/>
+            </a:pPr>
+            <a:r>
+              <a:t>3. Domain Gap: Human genome pre-training doesn't translate perfectly to viruses.</a:t>
             </a:r>
           </a:p>
         </p:txBody>
@@ -3439,7 +3422,7 @@
           <a:lstStyle/>
           <a:p>
             <a:r>
-              <a:t>Limitations &amp; Challenges</a:t>
+              <a:t>Deployment Strategy</a:t>
             </a:r>
           </a:p>
         </p:txBody>
@@ -3464,7 +3447,7 @@
               <a:defRPr sz="2000"/>
             </a:pPr>
             <a:r>
-              <a:t>1. Extreme Geographical Imbalance: Hard for spatial models (CNN) to overcome.</a:t>
+              <a:t>Decoupled production deployment module.</a:t>
             </a:r>
           </a:p>
           <a:p>
@@ -3472,7 +3455,7 @@
               <a:defRPr sz="2000"/>
             </a:pPr>
             <a:r>
-              <a:t>2. Computational Limits: VRAM restricted DNABERT's ability to learn 3000bp sequences.</a:t>
+              <a:t>Automatically loads the highest-performing architecture (BiLSTM).</a:t>
             </a:r>
           </a:p>
           <a:p>
@@ -3480,7 +3463,7 @@
               <a:defRPr sz="2000"/>
             </a:pPr>
             <a:r>
-              <a:t>3. Domain Gap: Human genome pre-training doesn't translate perfectly to viruses.</a:t>
+              <a:t>Ready for real-time FASTA inference.</a:t>
             </a:r>
           </a:p>
         </p:txBody>
@@ -3519,86 +3502,6 @@
           <a:lstStyle/>
           <a:p>
             <a:r>
-              <a:t>Deployment Strategy</a:t>
-            </a:r>
-          </a:p>
-        </p:txBody>
-      </p:sp>
-      <p:sp>
-        <p:nvSpPr>
-          <p:cNvPr id="3" name="Content Placeholder 2"/>
-          <p:cNvSpPr>
-            <a:spLocks noGrp="1"/>
-          </p:cNvSpPr>
-          <p:nvPr>
-            <p:ph idx="1"/>
-          </p:nvPr>
-        </p:nvSpPr>
-        <p:spPr/>
-        <p:txBody>
-          <a:bodyPr/>
-          <a:lstStyle/>
-          <a:p/>
-          <a:p>
-            <a:pPr>
-              <a:defRPr sz="2000"/>
-            </a:pPr>
-            <a:r>
-              <a:t>Decoupled production deployment module.</a:t>
-            </a:r>
-          </a:p>
-          <a:p>
-            <a:pPr>
-              <a:defRPr sz="2000"/>
-            </a:pPr>
-            <a:r>
-              <a:t>Automatically loads the highest-performing architecture (BiLSTM).</a:t>
-            </a:r>
-          </a:p>
-          <a:p>
-            <a:pPr>
-              <a:defRPr sz="2000"/>
-            </a:pPr>
-            <a:r>
-              <a:t>Ready for real-time FASTA inference.</a:t>
-            </a:r>
-          </a:p>
-        </p:txBody>
-      </p:sp>
-    </p:spTree>
-  </p:cSld>
-  <p:clrMapOvr>
-    <a:masterClrMapping/>
-  </p:clrMapOvr>
-</p:sld>
-</file>
-
-<file path=ppt/slides/slide15.xml><?xml version="1.0" encoding="utf-8"?>
-<p:sld xmlns:a="http://schemas.openxmlformats.org/drawingml/2006/main" xmlns:p="http://schemas.openxmlformats.org/presentationml/2006/main" xmlns:r="http://schemas.openxmlformats.org/officeDocument/2006/relationships">
-  <p:cSld>
-    <p:spTree>
-      <p:nvGrpSpPr>
-        <p:cNvPr id="1" name=""/>
-        <p:cNvGrpSpPr/>
-        <p:nvPr/>
-      </p:nvGrpSpPr>
-      <p:grpSpPr/>
-      <p:sp>
-        <p:nvSpPr>
-          <p:cNvPr id="2" name="Title 1"/>
-          <p:cNvSpPr>
-            <a:spLocks noGrp="1"/>
-          </p:cNvSpPr>
-          <p:nvPr>
-            <p:ph type="title"/>
-          </p:nvPr>
-        </p:nvSpPr>
-        <p:spPr/>
-        <p:txBody>
-          <a:bodyPr/>
-          <a:lstStyle/>
-          <a:p>
-            <a:r>
               <a:t>Conclusion &amp; Future Work</a:t>
             </a:r>
           </a:p>
@@ -3789,7 +3692,7 @@
           <a:p/>
           <a:p>
             <a:pPr>
-              <a:defRPr sz="1400"/>
+              <a:defRPr sz="2000"/>
             </a:pPr>
             <a:r>
               <a:t>Data was acquired by parsing 9,270 HIV-1 pol gene accessions utilized in the Kameris et al. experiment.</a:t>
@@ -3797,7 +3700,7 @@
           </a:p>
           <a:p>
             <a:pPr>
-              <a:defRPr sz="1400"/>
+              <a:defRPr sz="2000"/>
             </a:pPr>
             <a:r>
               <a:t>A JSON file was pulled from the Kameris GitHub repository to extract specific LANL sequence IDs.</a:t>
@@ -3805,7 +3708,7 @@
           </a:p>
           <a:p>
             <a:pPr>
-              <a:defRPr sz="1400"/>
+              <a:defRPr sz="2000"/>
             </a:pPr>
             <a:r>
               <a:t>These IDs were fed into the LANL HIV Sequence Database to batch download the raw FASTA sequences.</a:t>
@@ -3813,7 +3716,7 @@
           </a:p>
           <a:p>
             <a:pPr>
-              <a:defRPr sz="1400"/>
+              <a:defRPr sz="2000"/>
             </a:pPr>
             <a:r>
               <a:t>Sequences were then strictly filtered to our 4 target classes: Subtypes A, B, C, and D.</a:t>
@@ -3821,7 +3724,7 @@
           </a:p>
           <a:p>
             <a:pPr>
-              <a:defRPr sz="1400"/>
+              <a:defRPr sz="2000"/>
             </a:pPr>
             <a:r>
               <a:t>Severe Bias: Subtype B heavily dominates the final dataset (52.2%).</a:t>
@@ -3829,30 +3732,6 @@
           </a:p>
         </p:txBody>
       </p:sp>
-      <p:pic>
-        <p:nvPicPr>
-          <p:cNvPr id="4" name="Picture 3" descr="subtype_distribution.png"/>
-          <p:cNvPicPr>
-            <a:picLocks noChangeAspect="1"/>
-          </p:cNvPicPr>
-          <p:nvPr/>
-        </p:nvPicPr>
-        <p:blipFill>
-          <a:blip r:embed="rId2"/>
-          <a:stretch>
-            <a:fillRect/>
-          </a:stretch>
-        </p:blipFill>
-        <p:spPr>
-          <a:xfrm>
-            <a:off x="4114800" y="1371600"/>
-            <a:ext cx="4572000" cy="1766619"/>
-          </a:xfrm>
-          <a:prstGeom prst="rect">
-            <a:avLst/>
-          </a:prstGeom>
-        </p:spPr>
-      </p:pic>
     </p:spTree>
   </p:cSld>
   <p:clrMapOvr>
@@ -3887,7 +3766,7 @@
           <a:lstStyle/>
           <a:p>
             <a:r>
-              <a:t>Methodology: Processing &amp; Encoding</a:t>
+              <a:t>Methodology: Processing &amp; Class Balancing</a:t>
             </a:r>
           </a:p>
         </p:txBody>
@@ -3899,43 +3778,108 @@
             <a:spLocks noGrp="1"/>
           </p:cNvSpPr>
           <p:nvPr>
-            <p:ph idx="1"/>
-          </p:nvPr>
-        </p:nvSpPr>
-        <p:spPr/>
-        <p:txBody>
-          <a:bodyPr/>
-          <a:lstStyle/>
-          <a:p/>
+            <p:ph idx="1" sz="half"/>
+          </p:nvPr>
+        </p:nvSpPr>
+        <p:spPr/>
+        <p:txBody>
+          <a:bodyPr/>
+          <a:lstStyle/>
+          <a:p>
+            <a:r>
+              <a:t>Gap Splitting &amp; Encoding</a:t>
+            </a:r>
+          </a:p>
           <a:p>
             <a:pPr>
-              <a:defRPr sz="1400"/>
+              <a:defRPr sz="1600"/>
             </a:pPr>
             <a:r>
-              <a:t>Alignment gaps ('-') completely stripped.</a:t>
+              <a:t>• Alignment gaps ('-') completely stripped. Sequences padded to 3000bp.</a:t>
             </a:r>
           </a:p>
           <a:p>
             <a:pPr>
-              <a:defRPr sz="1400"/>
+              <a:defRPr sz="1600"/>
             </a:pPr>
             <a:r>
-              <a:t>1. One-Hot Encoding: Used for MLP and 1D-CNN.</a:t>
+              <a:t>• Before: 'A-T-C' -&gt; After: 'ATC' -&gt; [1, 4, 2, 0...]</a:t>
             </a:r>
           </a:p>
           <a:p>
             <a:pPr>
-              <a:defRPr sz="1400"/>
+              <a:defRPr sz="1600"/>
             </a:pPr>
             <a:r>
-              <a:t>2. Label Embedding: Integers used for BiLSTM inputs.</a:t>
+              <a:t>• One-Hot Encoding: Used for MLP and 1D-CNN.</a:t>
+            </a:r>
+          </a:p>
+          <a:p>
+            <a:pPr>
+              <a:defRPr sz="1600"/>
+            </a:pPr>
+            <a:r>
+              <a:t>• Label Embedding: Integer mapping used for BiLSTM.</a:t>
+            </a:r>
+          </a:p>
+        </p:txBody>
+      </p:sp>
+      <p:sp>
+        <p:nvSpPr>
+          <p:cNvPr id="4" name="Content Placeholder 3"/>
+          <p:cNvSpPr>
+            <a:spLocks noGrp="1"/>
+          </p:cNvSpPr>
+          <p:nvPr>
+            <p:ph idx="2" sz="half"/>
+          </p:nvPr>
+        </p:nvSpPr>
+        <p:spPr/>
+        <p:txBody>
+          <a:bodyPr/>
+          <a:lstStyle/>
+          <a:p>
+            <a:r>
+              <a:t>Addressing Class Imbalance</a:t>
+            </a:r>
+          </a:p>
+          <a:p>
+            <a:pPr>
+              <a:defRPr sz="1600"/>
+            </a:pPr>
+            <a:r>
+              <a:t>• Subtype B severely dominates the data.</a:t>
+            </a:r>
+          </a:p>
+          <a:p>
+            <a:pPr>
+              <a:defRPr sz="1600"/>
+            </a:pPr>
+            <a:r>
+              <a:t>• Standard cross-entropy caused precision collapse.</a:t>
+            </a:r>
+          </a:p>
+          <a:p>
+            <a:pPr>
+              <a:defRPr sz="1600"/>
+            </a:pPr>
+            <a:r>
+              <a:t>• Solution: Pure Focal Loss (Gamma=2.0).</a:t>
+            </a:r>
+          </a:p>
+          <a:p>
+            <a:pPr>
+              <a:defRPr sz="1600"/>
+            </a:pPr>
+            <a:r>
+              <a:t>• Forces gradient to focus on hard-to-predict minority strains (A, C, D).</a:t>
             </a:r>
           </a:p>
         </p:txBody>
       </p:sp>
       <p:pic>
         <p:nvPicPr>
-          <p:cNvPr id="4" name="Picture 3" descr="subtype_distribution.png"/>
+          <p:cNvPr id="5" name="Picture 4" descr="sequence_lengths.png"/>
           <p:cNvPicPr>
             <a:picLocks noChangeAspect="1"/>
           </p:cNvPicPr>
@@ -3949,8 +3893,32 @@
         </p:blipFill>
         <p:spPr>
           <a:xfrm>
-            <a:off x="4114800" y="1371600"/>
-            <a:ext cx="4572000" cy="1766619"/>
+            <a:off x="457200" y="4114800"/>
+            <a:ext cx="3657600" cy="1999185"/>
+          </a:xfrm>
+          <a:prstGeom prst="rect">
+            <a:avLst/>
+          </a:prstGeom>
+        </p:spPr>
+      </p:pic>
+      <p:pic>
+        <p:nvPicPr>
+          <p:cNvPr id="6" name="Picture 5" descr="subtype_distribution.png"/>
+          <p:cNvPicPr>
+            <a:picLocks noChangeAspect="1"/>
+          </p:cNvPicPr>
+          <p:nvPr/>
+        </p:nvPicPr>
+        <p:blipFill>
+          <a:blip r:embed="rId3"/>
+          <a:stretch>
+            <a:fillRect/>
+          </a:stretch>
+        </p:blipFill>
+        <p:spPr>
+          <a:xfrm>
+            <a:off x="4754880" y="4114800"/>
+            <a:ext cx="3657600" cy="1413295"/>
           </a:xfrm>
           <a:prstGeom prst="rect">
             <a:avLst/>
@@ -3991,7 +3959,7 @@
           <a:lstStyle/>
           <a:p>
             <a:r>
-              <a:t>Methodology: Class Balancing</a:t>
+              <a:t>Methodology: Architectures</a:t>
             </a:r>
           </a:p>
         </p:txBody>
@@ -4016,7 +3984,7 @@
               <a:defRPr sz="2000"/>
             </a:pPr>
             <a:r>
-              <a:t>Standard categorical cross-entropy caused precision degradation.</a:t>
+              <a:t>1. Baseline MLP (73.8k Params): GlobalAvgPool -&gt; Dense(16) -&gt; Classifier.</a:t>
             </a:r>
           </a:p>
           <a:p>
@@ -4024,7 +3992,7 @@
               <a:defRPr sz="2000"/>
             </a:pPr>
             <a:r>
-              <a:t>Implemented pure Focal Loss (Gamma=2.0).</a:t>
+              <a:t>2. 1D-CNN (200k Params): 4 Conv1D layers (filters: 32 to 128) alternating with MaxPool &amp; Dropout (0.5).</a:t>
             </a:r>
           </a:p>
           <a:p>
@@ -4032,7 +4000,7 @@
               <a:defRPr sz="2000"/>
             </a:pPr>
             <a:r>
-              <a:t>Forces the gradient to focus heavily on hard-to-predict minority strains (A, C, D).</a:t>
+              <a:t>3. BiLSTM (2.1M Params): 128-dim Embedding -&gt; 2-layer Bidirectional LSTM (256 hidden) -&gt; Dense(128).</a:t>
             </a:r>
           </a:p>
         </p:txBody>
@@ -4046,86 +4014,6 @@
 </file>
 
 <file path=ppt/slides/slide6.xml><?xml version="1.0" encoding="utf-8"?>
-<p:sld xmlns:a="http://schemas.openxmlformats.org/drawingml/2006/main" xmlns:p="http://schemas.openxmlformats.org/presentationml/2006/main" xmlns:r="http://schemas.openxmlformats.org/officeDocument/2006/relationships">
-  <p:cSld>
-    <p:spTree>
-      <p:nvGrpSpPr>
-        <p:cNvPr id="1" name=""/>
-        <p:cNvGrpSpPr/>
-        <p:nvPr/>
-      </p:nvGrpSpPr>
-      <p:grpSpPr/>
-      <p:sp>
-        <p:nvSpPr>
-          <p:cNvPr id="2" name="Title 1"/>
-          <p:cNvSpPr>
-            <a:spLocks noGrp="1"/>
-          </p:cNvSpPr>
-          <p:nvPr>
-            <p:ph type="title"/>
-          </p:nvPr>
-        </p:nvSpPr>
-        <p:spPr/>
-        <p:txBody>
-          <a:bodyPr/>
-          <a:lstStyle/>
-          <a:p>
-            <a:r>
-              <a:t>Methodology: Architectures</a:t>
-            </a:r>
-          </a:p>
-        </p:txBody>
-      </p:sp>
-      <p:sp>
-        <p:nvSpPr>
-          <p:cNvPr id="3" name="Content Placeholder 2"/>
-          <p:cNvSpPr>
-            <a:spLocks noGrp="1"/>
-          </p:cNvSpPr>
-          <p:nvPr>
-            <p:ph idx="1"/>
-          </p:nvPr>
-        </p:nvSpPr>
-        <p:spPr/>
-        <p:txBody>
-          <a:bodyPr/>
-          <a:lstStyle/>
-          <a:p/>
-          <a:p>
-            <a:pPr>
-              <a:defRPr sz="2000"/>
-            </a:pPr>
-            <a:r>
-              <a:t>1. Baseline MLP (73.8k Params): GlobalAvgPool -&gt; Dense(16) -&gt; Classifier.</a:t>
-            </a:r>
-          </a:p>
-          <a:p>
-            <a:pPr>
-              <a:defRPr sz="2000"/>
-            </a:pPr>
-            <a:r>
-              <a:t>2. 1D-CNN (200k Params): 4 Conv1D layers (filters: 32 to 128) alternating with MaxPool &amp; Dropout (0.5).</a:t>
-            </a:r>
-          </a:p>
-          <a:p>
-            <a:pPr>
-              <a:defRPr sz="2000"/>
-            </a:pPr>
-            <a:r>
-              <a:t>3. BiLSTM (2.1M Params): 128-dim Embedding -&gt; 2-layer Bidirectional LSTM (256 hidden) -&gt; Dense(128).</a:t>
-            </a:r>
-          </a:p>
-        </p:txBody>
-      </p:sp>
-    </p:spTree>
-  </p:cSld>
-  <p:clrMapOvr>
-    <a:masterClrMapping/>
-  </p:clrMapOvr>
-</p:sld>
-</file>
-
-<file path=ppt/slides/slide7.xml><?xml version="1.0" encoding="utf-8"?>
 <p:sld xmlns:a="http://schemas.openxmlformats.org/drawingml/2006/main" xmlns:p="http://schemas.openxmlformats.org/presentationml/2006/main" xmlns:r="http://schemas.openxmlformats.org/officeDocument/2006/relationships">
   <p:cSld>
     <p:spTree>
@@ -4229,7 +4117,7 @@
 </p:sld>
 </file>
 
-<file path=ppt/slides/slide8.xml><?xml version="1.0" encoding="utf-8"?>
+<file path=ppt/slides/slide7.xml><?xml version="1.0" encoding="utf-8"?>
 <p:sld xmlns:a="http://schemas.openxmlformats.org/drawingml/2006/main" xmlns:p="http://schemas.openxmlformats.org/presentationml/2006/main" xmlns:r="http://schemas.openxmlformats.org/officeDocument/2006/relationships">
   <p:cSld>
     <p:spTree>
@@ -4301,7 +4189,7 @@
 </p:sld>
 </file>
 
-<file path=ppt/slides/slide9.xml><?xml version="1.0" encoding="utf-8"?>
+<file path=ppt/slides/slide8.xml><?xml version="1.0" encoding="utf-8"?>
 <p:sld xmlns:a="http://schemas.openxmlformats.org/drawingml/2006/main" xmlns:p="http://schemas.openxmlformats.org/presentationml/2006/main" xmlns:r="http://schemas.openxmlformats.org/officeDocument/2006/relationships">
   <p:cSld>
     <p:spTree>
@@ -4679,6 +4567,102 @@
 </p:sld>
 </file>
 
+<file path=ppt/slides/slide9.xml><?xml version="1.0" encoding="utf-8"?>
+<p:sld xmlns:a="http://schemas.openxmlformats.org/drawingml/2006/main" xmlns:p="http://schemas.openxmlformats.org/presentationml/2006/main" xmlns:r="http://schemas.openxmlformats.org/officeDocument/2006/relationships">
+  <p:cSld>
+    <p:spTree>
+      <p:nvGrpSpPr>
+        <p:cNvPr id="1" name=""/>
+        <p:cNvGrpSpPr/>
+        <p:nvPr/>
+      </p:nvGrpSpPr>
+      <p:grpSpPr/>
+      <p:sp>
+        <p:nvSpPr>
+          <p:cNvPr id="2" name="Title 1"/>
+          <p:cNvSpPr>
+            <a:spLocks noGrp="1"/>
+          </p:cNvSpPr>
+          <p:nvPr>
+            <p:ph type="title"/>
+          </p:nvPr>
+        </p:nvSpPr>
+        <p:spPr/>
+        <p:txBody>
+          <a:bodyPr/>
+          <a:lstStyle/>
+          <a:p>
+            <a:r>
+              <a:t>Results: Confusion Matrices</a:t>
+            </a:r>
+          </a:p>
+        </p:txBody>
+      </p:sp>
+      <p:sp>
+        <p:nvSpPr>
+          <p:cNvPr id="3" name="Content Placeholder 2"/>
+          <p:cNvSpPr>
+            <a:spLocks noGrp="1"/>
+          </p:cNvSpPr>
+          <p:nvPr>
+            <p:ph idx="1"/>
+          </p:nvPr>
+        </p:nvSpPr>
+        <p:spPr/>
+        <p:txBody>
+          <a:bodyPr/>
+          <a:lstStyle/>
+          <a:p/>
+          <a:p>
+            <a:pPr>
+              <a:defRPr sz="1400"/>
+            </a:pPr>
+            <a:r>
+              <a:t>BiLSTM accurately maps minority classes.</a:t>
+            </a:r>
+          </a:p>
+          <a:p>
+            <a:pPr>
+              <a:defRPr sz="1400"/>
+            </a:pPr>
+            <a:r>
+              <a:t>CNN and DNABERT collapsed entirely (52.22% Subtype B baseline).</a:t>
+            </a:r>
+          </a:p>
+        </p:txBody>
+      </p:sp>
+      <p:pic>
+        <p:nvPicPr>
+          <p:cNvPr id="4" name="Picture 3" descr="all_confusion_matrices.png"/>
+          <p:cNvPicPr>
+            <a:picLocks noChangeAspect="1"/>
+          </p:cNvPicPr>
+          <p:nvPr/>
+        </p:nvPicPr>
+        <p:blipFill>
+          <a:blip r:embed="rId2"/>
+          <a:stretch>
+            <a:fillRect/>
+          </a:stretch>
+        </p:blipFill>
+        <p:spPr>
+          <a:xfrm>
+            <a:off x="3657600" y="1371600"/>
+            <a:ext cx="5029200" cy="1052789"/>
+          </a:xfrm>
+          <a:prstGeom prst="rect">
+            <a:avLst/>
+          </a:prstGeom>
+        </p:spPr>
+      </p:pic>
+    </p:spTree>
+  </p:cSld>
+  <p:clrMapOvr>
+    <a:masterClrMapping/>
+  </p:clrMapOvr>
+</p:sld>
+</file>
+
 <file path=ppt/theme/theme1.xml><?xml version="1.0" encoding="utf-8"?>
 <a:theme xmlns:a="http://schemas.openxmlformats.org/drawingml/2006/main" name="Office Theme">
   <a:themeElements>

</xml_diff>

<commit_message>
Split processing and class balancing into distinct slides and update docx splits
</commit_message>
<xml_diff>
--- a/reports/presentation.pptx
+++ b/reports/presentation.pptx
@@ -19,6 +19,7 @@
     <p:sldId id="267" r:id="rId18"/>
     <p:sldId id="268" r:id="rId19"/>
     <p:sldId id="269" r:id="rId20"/>
+    <p:sldId id="270" r:id="rId21"/>
   </p:sldIdLst>
   <p:sldSz cx="9144000" cy="6858000" type="screen4x3"/>
   <p:notesSz cx="6858000" cy="9144000"/>
@@ -3182,6 +3183,102 @@
           <a:lstStyle/>
           <a:p>
             <a:r>
+              <a:t>Results: Confusion Matrices</a:t>
+            </a:r>
+          </a:p>
+        </p:txBody>
+      </p:sp>
+      <p:sp>
+        <p:nvSpPr>
+          <p:cNvPr id="3" name="Content Placeholder 2"/>
+          <p:cNvSpPr>
+            <a:spLocks noGrp="1"/>
+          </p:cNvSpPr>
+          <p:nvPr>
+            <p:ph idx="1"/>
+          </p:nvPr>
+        </p:nvSpPr>
+        <p:spPr/>
+        <p:txBody>
+          <a:bodyPr/>
+          <a:lstStyle/>
+          <a:p/>
+          <a:p>
+            <a:pPr>
+              <a:defRPr sz="1400"/>
+            </a:pPr>
+            <a:r>
+              <a:t>BiLSTM accurately maps minority classes.</a:t>
+            </a:r>
+          </a:p>
+          <a:p>
+            <a:pPr>
+              <a:defRPr sz="1400"/>
+            </a:pPr>
+            <a:r>
+              <a:t>CNN and DNABERT collapsed entirely (52.22% Subtype B baseline).</a:t>
+            </a:r>
+          </a:p>
+        </p:txBody>
+      </p:sp>
+      <p:pic>
+        <p:nvPicPr>
+          <p:cNvPr id="4" name="Picture 3" descr="all_confusion_matrices.png"/>
+          <p:cNvPicPr>
+            <a:picLocks noChangeAspect="1"/>
+          </p:cNvPicPr>
+          <p:nvPr/>
+        </p:nvPicPr>
+        <p:blipFill>
+          <a:blip r:embed="rId2"/>
+          <a:stretch>
+            <a:fillRect/>
+          </a:stretch>
+        </p:blipFill>
+        <p:spPr>
+          <a:xfrm>
+            <a:off x="3657600" y="1371600"/>
+            <a:ext cx="5029200" cy="1052789"/>
+          </a:xfrm>
+          <a:prstGeom prst="rect">
+            <a:avLst/>
+          </a:prstGeom>
+        </p:spPr>
+      </p:pic>
+    </p:spTree>
+  </p:cSld>
+  <p:clrMapOvr>
+    <a:masterClrMapping/>
+  </p:clrMapOvr>
+</p:sld>
+</file>
+
+<file path=ppt/slides/slide11.xml><?xml version="1.0" encoding="utf-8"?>
+<p:sld xmlns:a="http://schemas.openxmlformats.org/drawingml/2006/main" xmlns:p="http://schemas.openxmlformats.org/presentationml/2006/main" xmlns:r="http://schemas.openxmlformats.org/officeDocument/2006/relationships">
+  <p:cSld>
+    <p:spTree>
+      <p:nvGrpSpPr>
+        <p:cNvPr id="1" name=""/>
+        <p:cNvGrpSpPr/>
+        <p:nvPr/>
+      </p:nvGrpSpPr>
+      <p:grpSpPr/>
+      <p:sp>
+        <p:nvSpPr>
+          <p:cNvPr id="2" name="Title 1"/>
+          <p:cNvSpPr>
+            <a:spLocks noGrp="1"/>
+          </p:cNvSpPr>
+          <p:nvPr>
+            <p:ph type="title"/>
+          </p:nvPr>
+        </p:nvSpPr>
+        <p:spPr/>
+        <p:txBody>
+          <a:bodyPr/>
+          <a:lstStyle/>
+          <a:p>
+            <a:r>
               <a:t>Results: ROC Curves</a:t>
             </a:r>
           </a:p>
@@ -3244,78 +3341,6 @@
 </p:sld>
 </file>
 
-<file path=ppt/slides/slide11.xml><?xml version="1.0" encoding="utf-8"?>
-<p:sld xmlns:a="http://schemas.openxmlformats.org/drawingml/2006/main" xmlns:p="http://schemas.openxmlformats.org/presentationml/2006/main" xmlns:r="http://schemas.openxmlformats.org/officeDocument/2006/relationships">
-  <p:cSld>
-    <p:spTree>
-      <p:nvGrpSpPr>
-        <p:cNvPr id="1" name=""/>
-        <p:cNvGrpSpPr/>
-        <p:nvPr/>
-      </p:nvGrpSpPr>
-      <p:grpSpPr/>
-      <p:sp>
-        <p:nvSpPr>
-          <p:cNvPr id="2" name="Title 1"/>
-          <p:cNvSpPr>
-            <a:spLocks noGrp="1"/>
-          </p:cNvSpPr>
-          <p:nvPr>
-            <p:ph type="title"/>
-          </p:nvPr>
-        </p:nvSpPr>
-        <p:spPr/>
-        <p:txBody>
-          <a:bodyPr/>
-          <a:lstStyle/>
-          <a:p>
-            <a:r>
-              <a:t>Error Analysis</a:t>
-            </a:r>
-          </a:p>
-        </p:txBody>
-      </p:sp>
-      <p:sp>
-        <p:nvSpPr>
-          <p:cNvPr id="3" name="Content Placeholder 2"/>
-          <p:cNvSpPr>
-            <a:spLocks noGrp="1"/>
-          </p:cNvSpPr>
-          <p:nvPr>
-            <p:ph idx="1"/>
-          </p:nvPr>
-        </p:nvSpPr>
-        <p:spPr/>
-        <p:txBody>
-          <a:bodyPr/>
-          <a:lstStyle/>
-          <a:p/>
-          <a:p>
-            <a:pPr>
-              <a:defRPr sz="2000"/>
-            </a:pPr>
-            <a:r>
-              <a:t>Causes: CNNs and DNABERT collapsed due to geographic imbalance.</a:t>
-            </a:r>
-          </a:p>
-          <a:p>
-            <a:pPr>
-              <a:defRPr sz="2000"/>
-            </a:pPr>
-            <a:r>
-              <a:t>Implications: Saliency Maps show BiLSTMs rely on conserved regions. When 'viral drift' mutates these domains, confidence drops.</a:t>
-            </a:r>
-          </a:p>
-        </p:txBody>
-      </p:sp>
-    </p:spTree>
-  </p:cSld>
-  <p:clrMapOvr>
-    <a:masterClrMapping/>
-  </p:clrMapOvr>
-</p:sld>
-</file>
-
 <file path=ppt/slides/slide12.xml><?xml version="1.0" encoding="utf-8"?>
 <p:sld xmlns:a="http://schemas.openxmlformats.org/drawingml/2006/main" xmlns:p="http://schemas.openxmlformats.org/presentationml/2006/main" xmlns:r="http://schemas.openxmlformats.org/officeDocument/2006/relationships">
   <p:cSld>
@@ -3342,7 +3367,7 @@
           <a:lstStyle/>
           <a:p>
             <a:r>
-              <a:t>Limitations &amp; Challenges</a:t>
+              <a:t>Error Analysis</a:t>
             </a:r>
           </a:p>
         </p:txBody>
@@ -3367,7 +3392,7 @@
               <a:defRPr sz="2000"/>
             </a:pPr>
             <a:r>
-              <a:t>1. Extreme Geographical Imbalance: Hard for spatial models (CNN) to overcome.</a:t>
+              <a:t>Causes: CNNs and DNABERT collapsed due to geographic imbalance.</a:t>
             </a:r>
           </a:p>
           <a:p>
@@ -3375,15 +3400,7 @@
               <a:defRPr sz="2000"/>
             </a:pPr>
             <a:r>
-              <a:t>2. Computational Limits: VRAM restricted DNABERT's ability to learn 3000bp sequences.</a:t>
-            </a:r>
-          </a:p>
-          <a:p>
-            <a:pPr>
-              <a:defRPr sz="2000"/>
-            </a:pPr>
-            <a:r>
-              <a:t>3. Domain Gap: Human genome pre-training doesn't translate perfectly to viruses.</a:t>
+              <a:t>Implications: Saliency Maps show BiLSTMs rely on conserved regions. When 'viral drift' mutates these domains, confidence drops.</a:t>
             </a:r>
           </a:p>
         </p:txBody>
@@ -3422,7 +3439,7 @@
           <a:lstStyle/>
           <a:p>
             <a:r>
-              <a:t>Deployment Strategy</a:t>
+              <a:t>Limitations &amp; Challenges</a:t>
             </a:r>
           </a:p>
         </p:txBody>
@@ -3447,7 +3464,7 @@
               <a:defRPr sz="2000"/>
             </a:pPr>
             <a:r>
-              <a:t>Decoupled production deployment module.</a:t>
+              <a:t>1. Extreme Geographical Imbalance: Hard for spatial models (CNN) to overcome.</a:t>
             </a:r>
           </a:p>
           <a:p>
@@ -3455,7 +3472,7 @@
               <a:defRPr sz="2000"/>
             </a:pPr>
             <a:r>
-              <a:t>Automatically loads the highest-performing architecture (BiLSTM).</a:t>
+              <a:t>2. Computational Limits: VRAM restricted DNABERT's ability to learn 3000bp sequences.</a:t>
             </a:r>
           </a:p>
           <a:p>
@@ -3463,7 +3480,7 @@
               <a:defRPr sz="2000"/>
             </a:pPr>
             <a:r>
-              <a:t>Ready for real-time FASTA inference.</a:t>
+              <a:t>3. Domain Gap: Human genome pre-training doesn't translate perfectly to viruses.</a:t>
             </a:r>
           </a:p>
         </p:txBody>
@@ -3502,6 +3519,86 @@
           <a:lstStyle/>
           <a:p>
             <a:r>
+              <a:t>Deployment Strategy</a:t>
+            </a:r>
+          </a:p>
+        </p:txBody>
+      </p:sp>
+      <p:sp>
+        <p:nvSpPr>
+          <p:cNvPr id="3" name="Content Placeholder 2"/>
+          <p:cNvSpPr>
+            <a:spLocks noGrp="1"/>
+          </p:cNvSpPr>
+          <p:nvPr>
+            <p:ph idx="1"/>
+          </p:nvPr>
+        </p:nvSpPr>
+        <p:spPr/>
+        <p:txBody>
+          <a:bodyPr/>
+          <a:lstStyle/>
+          <a:p/>
+          <a:p>
+            <a:pPr>
+              <a:defRPr sz="2000"/>
+            </a:pPr>
+            <a:r>
+              <a:t>Decoupled production deployment module.</a:t>
+            </a:r>
+          </a:p>
+          <a:p>
+            <a:pPr>
+              <a:defRPr sz="2000"/>
+            </a:pPr>
+            <a:r>
+              <a:t>Automatically loads the highest-performing architecture (BiLSTM).</a:t>
+            </a:r>
+          </a:p>
+          <a:p>
+            <a:pPr>
+              <a:defRPr sz="2000"/>
+            </a:pPr>
+            <a:r>
+              <a:t>Ready for real-time FASTA inference.</a:t>
+            </a:r>
+          </a:p>
+        </p:txBody>
+      </p:sp>
+    </p:spTree>
+  </p:cSld>
+  <p:clrMapOvr>
+    <a:masterClrMapping/>
+  </p:clrMapOvr>
+</p:sld>
+</file>
+
+<file path=ppt/slides/slide15.xml><?xml version="1.0" encoding="utf-8"?>
+<p:sld xmlns:a="http://schemas.openxmlformats.org/drawingml/2006/main" xmlns:p="http://schemas.openxmlformats.org/presentationml/2006/main" xmlns:r="http://schemas.openxmlformats.org/officeDocument/2006/relationships">
+  <p:cSld>
+    <p:spTree>
+      <p:nvGrpSpPr>
+        <p:cNvPr id="1" name=""/>
+        <p:cNvGrpSpPr/>
+        <p:nvPr/>
+      </p:nvGrpSpPr>
+      <p:grpSpPr/>
+      <p:sp>
+        <p:nvSpPr>
+          <p:cNvPr id="2" name="Title 1"/>
+          <p:cNvSpPr>
+            <a:spLocks noGrp="1"/>
+          </p:cNvSpPr>
+          <p:nvPr>
+            <p:ph type="title"/>
+          </p:nvPr>
+        </p:nvSpPr>
+        <p:spPr/>
+        <p:txBody>
+          <a:bodyPr/>
+          <a:lstStyle/>
+          <a:p>
+            <a:r>
               <a:t>Conclusion &amp; Future Work</a:t>
             </a:r>
           </a:p>
@@ -3766,7 +3863,7 @@
           <a:lstStyle/>
           <a:p>
             <a:r>
-              <a:t>Methodology: Processing &amp; Class Balancing</a:t>
+              <a:t>Methodology: Processing &amp; Encoding</a:t>
             </a:r>
           </a:p>
         </p:txBody>
@@ -3778,24 +3875,20 @@
             <a:spLocks noGrp="1"/>
           </p:cNvSpPr>
           <p:nvPr>
-            <p:ph idx="1" sz="half"/>
-          </p:nvPr>
-        </p:nvSpPr>
-        <p:spPr/>
-        <p:txBody>
-          <a:bodyPr/>
-          <a:lstStyle/>
-          <a:p>
-            <a:r>
-              <a:t>Gap Splitting &amp; Encoding</a:t>
-            </a:r>
-          </a:p>
+            <p:ph idx="1"/>
+          </p:nvPr>
+        </p:nvSpPr>
+        <p:spPr/>
+        <p:txBody>
+          <a:bodyPr/>
+          <a:lstStyle/>
+          <a:p/>
           <a:p>
             <a:pPr>
               <a:defRPr sz="1600"/>
             </a:pPr>
             <a:r>
-              <a:t>• Alignment gaps ('-') completely stripped. Sequences padded to 3000bp.</a:t>
+              <a:t>• Gap Stripping: Alignment gaps ('-') completely removed.</a:t>
             </a:r>
           </a:p>
           <a:p>
@@ -3803,7 +3896,7 @@
               <a:defRPr sz="1600"/>
             </a:pPr>
             <a:r>
-              <a:t>• Before: 'A-T-C' -&gt; After: 'ATC' -&gt; [1, 4, 2, 0...]</a:t>
+              <a:t>• Padding: Unaligned sequences padded/truncated to uniform 3000bp.</a:t>
             </a:r>
           </a:p>
           <a:p>
@@ -3811,7 +3904,7 @@
               <a:defRPr sz="1600"/>
             </a:pPr>
             <a:r>
-              <a:t>• One-Hot Encoding: Used for MLP and 1D-CNN.</a:t>
+              <a:t>• One-Hot Encoding: Matrix [L x 4] for spatial models (CNN, MLP).</a:t>
             </a:r>
           </a:p>
           <a:p>
@@ -3819,64 +3912,179 @@
               <a:defRPr sz="1600"/>
             </a:pPr>
             <a:r>
-              <a:t>• Label Embedding: Integer mapping used for BiLSTM.</a:t>
-            </a:r>
-          </a:p>
-        </p:txBody>
-      </p:sp>
-      <p:sp>
-        <p:nvSpPr>
-          <p:cNvPr id="4" name="Content Placeholder 3"/>
-          <p:cNvSpPr>
-            <a:spLocks noGrp="1"/>
-          </p:cNvSpPr>
-          <p:nvPr>
-            <p:ph idx="2" sz="half"/>
-          </p:nvPr>
-        </p:nvSpPr>
-        <p:spPr/>
-        <p:txBody>
-          <a:bodyPr/>
-          <a:lstStyle/>
-          <a:p>
-            <a:r>
-              <a:t>Addressing Class Imbalance</a:t>
-            </a:r>
-          </a:p>
-          <a:p>
-            <a:pPr>
-              <a:defRPr sz="1600"/>
-            </a:pPr>
-            <a:r>
-              <a:t>• Subtype B severely dominates the data.</a:t>
-            </a:r>
-          </a:p>
-          <a:p>
-            <a:pPr>
-              <a:defRPr sz="1600"/>
-            </a:pPr>
-            <a:r>
-              <a:t>• Standard cross-entropy caused precision collapse.</a:t>
-            </a:r>
-          </a:p>
-          <a:p>
-            <a:pPr>
-              <a:defRPr sz="1600"/>
-            </a:pPr>
-            <a:r>
-              <a:t>• Solution: Pure Focal Loss (Gamma=2.0).</a:t>
-            </a:r>
-          </a:p>
-          <a:p>
-            <a:pPr>
-              <a:defRPr sz="1600"/>
-            </a:pPr>
-            <a:r>
-              <a:t>• Forces gradient to focus on hard-to-predict minority strains (A, C, D).</a:t>
-            </a:r>
-          </a:p>
-        </p:txBody>
-      </p:sp>
+              <a:t>• Label Embedding: Integer mapping for sequential models (BiLSTM).</a:t>
+            </a:r>
+          </a:p>
+        </p:txBody>
+      </p:sp>
+      <p:graphicFrame>
+        <p:nvGraphicFramePr>
+          <p:cNvPr id="4" name="Table 3"/>
+          <p:cNvGraphicFramePr>
+            <a:graphicFrameLocks noGrp="1"/>
+          </p:cNvGraphicFramePr>
+          <p:nvPr/>
+        </p:nvGraphicFramePr>
+        <p:xfrm>
+          <a:off x="457200" y="2743200"/>
+          <a:ext cx="4114800" cy="1371600"/>
+        </p:xfrm>
+        <a:graphic>
+          <a:graphicData uri="http://schemas.openxmlformats.org/drawingml/2006/table">
+            <a:tbl>
+              <a:tblPr firstRow="1" bandRow="1">
+                <a:tableStyleId>{5C22544A-7EE6-4342-B048-85BDC9FD1C3A}</a:tableStyleId>
+              </a:tblPr>
+              <a:tblGrid>
+                <a:gridCol w="1371600"/>
+                <a:gridCol w="1371600"/>
+                <a:gridCol w="1371600"/>
+              </a:tblGrid>
+              <a:tr h="457200">
+                <a:tc>
+                  <a:txBody>
+                    <a:bodyPr/>
+                    <a:lstStyle/>
+                    <a:p>
+                      <a:pPr>
+                        <a:defRPr sz="1400" b="1"/>
+                      </a:pPr>
+                      <a:r>
+                        <a:t>Raw Sequence</a:t>
+                      </a:r>
+                    </a:p>
+                  </a:txBody>
+                  <a:tcPr/>
+                </a:tc>
+                <a:tc>
+                  <a:txBody>
+                    <a:bodyPr/>
+                    <a:lstStyle/>
+                    <a:p>
+                      <a:pPr>
+                        <a:defRPr sz="1400" b="1"/>
+                      </a:pPr>
+                      <a:r>
+                        <a:t>Cleaned Sequence</a:t>
+                      </a:r>
+                    </a:p>
+                  </a:txBody>
+                  <a:tcPr/>
+                </a:tc>
+                <a:tc>
+                  <a:txBody>
+                    <a:bodyPr/>
+                    <a:lstStyle/>
+                    <a:p>
+                      <a:pPr>
+                        <a:defRPr sz="1400" b="1"/>
+                      </a:pPr>
+                      <a:r>
+                        <a:t>Integer Encoding</a:t>
+                      </a:r>
+                    </a:p>
+                  </a:txBody>
+                  <a:tcPr/>
+                </a:tc>
+              </a:tr>
+              <a:tr h="457200">
+                <a:tc>
+                  <a:txBody>
+                    <a:bodyPr/>
+                    <a:lstStyle/>
+                    <a:p>
+                      <a:pPr>
+                        <a:defRPr sz="1400" b="1"/>
+                      </a:pPr>
+                      <a:r>
+                        <a:t>A-T-C--G</a:t>
+                      </a:r>
+                    </a:p>
+                  </a:txBody>
+                  <a:tcPr/>
+                </a:tc>
+                <a:tc>
+                  <a:txBody>
+                    <a:bodyPr/>
+                    <a:lstStyle/>
+                    <a:p>
+                      <a:pPr>
+                        <a:defRPr sz="1400" b="1"/>
+                      </a:pPr>
+                      <a:r>
+                        <a:t>ATCG</a:t>
+                      </a:r>
+                    </a:p>
+                  </a:txBody>
+                  <a:tcPr/>
+                </a:tc>
+                <a:tc>
+                  <a:txBody>
+                    <a:bodyPr/>
+                    <a:lstStyle/>
+                    <a:p>
+                      <a:pPr>
+                        <a:defRPr sz="1400" b="1"/>
+                      </a:pPr>
+                      <a:r>
+                        <a:t>[1, 4, 2, 3]</a:t>
+                      </a:r>
+                    </a:p>
+                  </a:txBody>
+                  <a:tcPr/>
+                </a:tc>
+              </a:tr>
+              <a:tr h="457200">
+                <a:tc>
+                  <a:txBody>
+                    <a:bodyPr/>
+                    <a:lstStyle/>
+                    <a:p>
+                      <a:pPr>
+                        <a:defRPr sz="1400" b="1"/>
+                      </a:pPr>
+                      <a:r>
+                        <a:t>T--C-A-N</a:t>
+                      </a:r>
+                    </a:p>
+                  </a:txBody>
+                  <a:tcPr/>
+                </a:tc>
+                <a:tc>
+                  <a:txBody>
+                    <a:bodyPr/>
+                    <a:lstStyle/>
+                    <a:p>
+                      <a:pPr>
+                        <a:defRPr sz="1400" b="1"/>
+                      </a:pPr>
+                      <a:r>
+                        <a:t>TCAN</a:t>
+                      </a:r>
+                    </a:p>
+                  </a:txBody>
+                  <a:tcPr/>
+                </a:tc>
+                <a:tc>
+                  <a:txBody>
+                    <a:bodyPr/>
+                    <a:lstStyle/>
+                    <a:p>
+                      <a:pPr>
+                        <a:defRPr sz="1400" b="1"/>
+                      </a:pPr>
+                      <a:r>
+                        <a:t>[4, 2, 1, 0]</a:t>
+                      </a:r>
+                    </a:p>
+                  </a:txBody>
+                  <a:tcPr/>
+                </a:tc>
+              </a:tr>
+            </a:tbl>
+          </a:graphicData>
+        </a:graphic>
+      </p:graphicFrame>
       <p:pic>
         <p:nvPicPr>
           <p:cNvPr id="5" name="Picture 4" descr="sequence_lengths.png"/>
@@ -3893,32 +4101,8 @@
         </p:blipFill>
         <p:spPr>
           <a:xfrm>
-            <a:off x="457200" y="4114800"/>
-            <a:ext cx="3657600" cy="1999185"/>
-          </a:xfrm>
-          <a:prstGeom prst="rect">
-            <a:avLst/>
-          </a:prstGeom>
-        </p:spPr>
-      </p:pic>
-      <p:pic>
-        <p:nvPicPr>
-          <p:cNvPr id="6" name="Picture 5" descr="subtype_distribution.png"/>
-          <p:cNvPicPr>
-            <a:picLocks noChangeAspect="1"/>
-          </p:cNvPicPr>
-          <p:nvPr/>
-        </p:nvPicPr>
-        <p:blipFill>
-          <a:blip r:embed="rId3"/>
-          <a:stretch>
-            <a:fillRect/>
-          </a:stretch>
-        </p:blipFill>
-        <p:spPr>
-          <a:xfrm>
-            <a:off x="4754880" y="4114800"/>
-            <a:ext cx="3657600" cy="1413295"/>
+            <a:off x="4754880" y="1828800"/>
+            <a:ext cx="4114800" cy="2249083"/>
           </a:xfrm>
           <a:prstGeom prst="rect">
             <a:avLst/>
@@ -3959,7 +4143,7 @@
           <a:lstStyle/>
           <a:p>
             <a:r>
-              <a:t>Methodology: Architectures</a:t>
+              <a:t>Methodology: Data Splitting &amp; Class Balancing</a:t>
             </a:r>
           </a:p>
         </p:txBody>
@@ -3981,30 +4165,70 @@
           <a:p/>
           <a:p>
             <a:pPr>
-              <a:defRPr sz="2000"/>
+              <a:defRPr sz="1600"/>
             </a:pPr>
             <a:r>
-              <a:t>1. Baseline MLP (73.8k Params): GlobalAvgPool -&gt; Dense(16) -&gt; Classifier.</a:t>
+              <a:t>• Stratified Split: Data divided into 70% Train, 15% Val, and 15% Test.</a:t>
             </a:r>
           </a:p>
           <a:p>
             <a:pPr>
-              <a:defRPr sz="2000"/>
+              <a:defRPr sz="1600"/>
             </a:pPr>
             <a:r>
-              <a:t>2. 1D-CNN (200k Params): 4 Conv1D layers (filters: 32 to 128) alternating with MaxPool &amp; Dropout (0.5).</a:t>
+              <a:t>• Class Imbalance: Subtype B severely dominates the data (&gt;52%).</a:t>
             </a:r>
           </a:p>
           <a:p>
             <a:pPr>
-              <a:defRPr sz="2000"/>
+              <a:defRPr sz="1600"/>
             </a:pPr>
             <a:r>
-              <a:t>3. BiLSTM (2.1M Params): 128-dim Embedding -&gt; 2-layer Bidirectional LSTM (256 hidden) -&gt; Dense(128).</a:t>
-            </a:r>
-          </a:p>
-        </p:txBody>
-      </p:sp>
+              <a:t>• Standard cross-entropy caused precision collapse in minority classes.</a:t>
+            </a:r>
+          </a:p>
+          <a:p>
+            <a:pPr>
+              <a:defRPr sz="1600"/>
+            </a:pPr>
+            <a:r>
+              <a:t>• Solution: Pure Focal Loss (Gamma=2.0) applied natively in PyTorch.</a:t>
+            </a:r>
+          </a:p>
+          <a:p>
+            <a:pPr>
+              <a:defRPr sz="1600"/>
+            </a:pPr>
+            <a:r>
+              <a:t>• Forces gradient to focus on hard-to-predict minority strains (A, C, D).</a:t>
+            </a:r>
+          </a:p>
+        </p:txBody>
+      </p:sp>
+      <p:pic>
+        <p:nvPicPr>
+          <p:cNvPr id="4" name="Picture 3" descr="subtype_distribution.png"/>
+          <p:cNvPicPr>
+            <a:picLocks noChangeAspect="1"/>
+          </p:cNvPicPr>
+          <p:nvPr/>
+        </p:nvPicPr>
+        <p:blipFill>
+          <a:blip r:embed="rId2"/>
+          <a:stretch>
+            <a:fillRect/>
+          </a:stretch>
+        </p:blipFill>
+        <p:spPr>
+          <a:xfrm>
+            <a:off x="4754880" y="3200400"/>
+            <a:ext cx="4114800" cy="1589957"/>
+          </a:xfrm>
+          <a:prstGeom prst="rect">
+            <a:avLst/>
+          </a:prstGeom>
+        </p:spPr>
+      </p:pic>
     </p:spTree>
   </p:cSld>
   <p:clrMapOvr>
@@ -4014,6 +4238,86 @@
 </file>
 
 <file path=ppt/slides/slide6.xml><?xml version="1.0" encoding="utf-8"?>
+<p:sld xmlns:a="http://schemas.openxmlformats.org/drawingml/2006/main" xmlns:p="http://schemas.openxmlformats.org/presentationml/2006/main" xmlns:r="http://schemas.openxmlformats.org/officeDocument/2006/relationships">
+  <p:cSld>
+    <p:spTree>
+      <p:nvGrpSpPr>
+        <p:cNvPr id="1" name=""/>
+        <p:cNvGrpSpPr/>
+        <p:nvPr/>
+      </p:nvGrpSpPr>
+      <p:grpSpPr/>
+      <p:sp>
+        <p:nvSpPr>
+          <p:cNvPr id="2" name="Title 1"/>
+          <p:cNvSpPr>
+            <a:spLocks noGrp="1"/>
+          </p:cNvSpPr>
+          <p:nvPr>
+            <p:ph type="title"/>
+          </p:nvPr>
+        </p:nvSpPr>
+        <p:spPr/>
+        <p:txBody>
+          <a:bodyPr/>
+          <a:lstStyle/>
+          <a:p>
+            <a:r>
+              <a:t>Methodology: Architectures</a:t>
+            </a:r>
+          </a:p>
+        </p:txBody>
+      </p:sp>
+      <p:sp>
+        <p:nvSpPr>
+          <p:cNvPr id="3" name="Content Placeholder 2"/>
+          <p:cNvSpPr>
+            <a:spLocks noGrp="1"/>
+          </p:cNvSpPr>
+          <p:nvPr>
+            <p:ph idx="1"/>
+          </p:nvPr>
+        </p:nvSpPr>
+        <p:spPr/>
+        <p:txBody>
+          <a:bodyPr/>
+          <a:lstStyle/>
+          <a:p/>
+          <a:p>
+            <a:pPr>
+              <a:defRPr sz="2000"/>
+            </a:pPr>
+            <a:r>
+              <a:t>1. Baseline MLP (73.8k Params): GlobalAvgPool -&gt; Dense(16) -&gt; Classifier.</a:t>
+            </a:r>
+          </a:p>
+          <a:p>
+            <a:pPr>
+              <a:defRPr sz="2000"/>
+            </a:pPr>
+            <a:r>
+              <a:t>2. 1D-CNN (200k Params): 4 Conv1D layers (filters: 32 to 128) alternating with MaxPool &amp; Dropout (0.5).</a:t>
+            </a:r>
+          </a:p>
+          <a:p>
+            <a:pPr>
+              <a:defRPr sz="2000"/>
+            </a:pPr>
+            <a:r>
+              <a:t>3. BiLSTM (2.1M Params): 128-dim Embedding -&gt; 2-layer Bidirectional LSTM (256 hidden) -&gt; Dense(128).</a:t>
+            </a:r>
+          </a:p>
+        </p:txBody>
+      </p:sp>
+    </p:spTree>
+  </p:cSld>
+  <p:clrMapOvr>
+    <a:masterClrMapping/>
+  </p:clrMapOvr>
+</p:sld>
+</file>
+
+<file path=ppt/slides/slide7.xml><?xml version="1.0" encoding="utf-8"?>
 <p:sld xmlns:a="http://schemas.openxmlformats.org/drawingml/2006/main" xmlns:p="http://schemas.openxmlformats.org/presentationml/2006/main" xmlns:r="http://schemas.openxmlformats.org/officeDocument/2006/relationships">
   <p:cSld>
     <p:spTree>
@@ -4117,7 +4421,7 @@
 </p:sld>
 </file>
 
-<file path=ppt/slides/slide7.xml><?xml version="1.0" encoding="utf-8"?>
+<file path=ppt/slides/slide8.xml><?xml version="1.0" encoding="utf-8"?>
 <p:sld xmlns:a="http://schemas.openxmlformats.org/drawingml/2006/main" xmlns:p="http://schemas.openxmlformats.org/presentationml/2006/main" xmlns:r="http://schemas.openxmlformats.org/officeDocument/2006/relationships">
   <p:cSld>
     <p:spTree>
@@ -4189,7 +4493,7 @@
 </p:sld>
 </file>
 
-<file path=ppt/slides/slide8.xml><?xml version="1.0" encoding="utf-8"?>
+<file path=ppt/slides/slide9.xml><?xml version="1.0" encoding="utf-8"?>
 <p:sld xmlns:a="http://schemas.openxmlformats.org/drawingml/2006/main" xmlns:p="http://schemas.openxmlformats.org/presentationml/2006/main" xmlns:r="http://schemas.openxmlformats.org/officeDocument/2006/relationships">
   <p:cSld>
     <p:spTree>
@@ -4567,102 +4871,6 @@
 </p:sld>
 </file>
 
-<file path=ppt/slides/slide9.xml><?xml version="1.0" encoding="utf-8"?>
-<p:sld xmlns:a="http://schemas.openxmlformats.org/drawingml/2006/main" xmlns:p="http://schemas.openxmlformats.org/presentationml/2006/main" xmlns:r="http://schemas.openxmlformats.org/officeDocument/2006/relationships">
-  <p:cSld>
-    <p:spTree>
-      <p:nvGrpSpPr>
-        <p:cNvPr id="1" name=""/>
-        <p:cNvGrpSpPr/>
-        <p:nvPr/>
-      </p:nvGrpSpPr>
-      <p:grpSpPr/>
-      <p:sp>
-        <p:nvSpPr>
-          <p:cNvPr id="2" name="Title 1"/>
-          <p:cNvSpPr>
-            <a:spLocks noGrp="1"/>
-          </p:cNvSpPr>
-          <p:nvPr>
-            <p:ph type="title"/>
-          </p:nvPr>
-        </p:nvSpPr>
-        <p:spPr/>
-        <p:txBody>
-          <a:bodyPr/>
-          <a:lstStyle/>
-          <a:p>
-            <a:r>
-              <a:t>Results: Confusion Matrices</a:t>
-            </a:r>
-          </a:p>
-        </p:txBody>
-      </p:sp>
-      <p:sp>
-        <p:nvSpPr>
-          <p:cNvPr id="3" name="Content Placeholder 2"/>
-          <p:cNvSpPr>
-            <a:spLocks noGrp="1"/>
-          </p:cNvSpPr>
-          <p:nvPr>
-            <p:ph idx="1"/>
-          </p:nvPr>
-        </p:nvSpPr>
-        <p:spPr/>
-        <p:txBody>
-          <a:bodyPr/>
-          <a:lstStyle/>
-          <a:p/>
-          <a:p>
-            <a:pPr>
-              <a:defRPr sz="1400"/>
-            </a:pPr>
-            <a:r>
-              <a:t>BiLSTM accurately maps minority classes.</a:t>
-            </a:r>
-          </a:p>
-          <a:p>
-            <a:pPr>
-              <a:defRPr sz="1400"/>
-            </a:pPr>
-            <a:r>
-              <a:t>CNN and DNABERT collapsed entirely (52.22% Subtype B baseline).</a:t>
-            </a:r>
-          </a:p>
-        </p:txBody>
-      </p:sp>
-      <p:pic>
-        <p:nvPicPr>
-          <p:cNvPr id="4" name="Picture 3" descr="all_confusion_matrices.png"/>
-          <p:cNvPicPr>
-            <a:picLocks noChangeAspect="1"/>
-          </p:cNvPicPr>
-          <p:nvPr/>
-        </p:nvPicPr>
-        <p:blipFill>
-          <a:blip r:embed="rId2"/>
-          <a:stretch>
-            <a:fillRect/>
-          </a:stretch>
-        </p:blipFill>
-        <p:spPr>
-          <a:xfrm>
-            <a:off x="3657600" y="1371600"/>
-            <a:ext cx="5029200" cy="1052789"/>
-          </a:xfrm>
-          <a:prstGeom prst="rect">
-            <a:avLst/>
-          </a:prstGeom>
-        </p:spPr>
-      </p:pic>
-    </p:spTree>
-  </p:cSld>
-  <p:clrMapOvr>
-    <a:masterClrMapping/>
-  </p:clrMapOvr>
-</p:sld>
-</file>
-
 <file path=ppt/theme/theme1.xml><?xml version="1.0" encoding="utf-8"?>
 <a:theme xmlns:a="http://schemas.openxmlformats.org/drawingml/2006/main" name="Office Theme">
   <a:themeElements>

</xml_diff>

<commit_message>
Apply premium dark blue styling, bold headers, and clean font sizing across the presentation
</commit_message>
<xml_diff>
--- a/reports/presentation.pptx
+++ b/reports/presentation.pptx
@@ -3117,6 +3117,14 @@
           <a:bodyPr/>
           <a:lstStyle/>
           <a:p>
+            <a:pPr>
+              <a:defRPr b="1">
+                <a:solidFill>
+                  <a:srgbClr val="14325A"/>
+                </a:solidFill>
+                <a:latin typeface="Segoe UI"/>
+              </a:defRPr>
+            </a:pPr>
             <a:r>
               <a:t>Deep Learning for HIV-1 Subtype Classification</a:t>
             </a:r>
@@ -3138,11 +3146,27 @@
           <a:bodyPr/>
           <a:lstStyle/>
           <a:p>
+            <a:pPr>
+              <a:defRPr>
+                <a:solidFill>
+                  <a:srgbClr val="505050"/>
+                </a:solidFill>
+                <a:latin typeface="Segoe UI"/>
+              </a:defRPr>
+            </a:pPr>
             <a:r>
               <a:t>A BiLSTM and Focal Loss Approach on unaligned pol Gene Sequences</a:t>
             </a:r>
           </a:p>
           <a:p>
+            <a:pPr>
+              <a:defRPr>
+                <a:solidFill>
+                  <a:srgbClr val="505050"/>
+                </a:solidFill>
+                <a:latin typeface="Segoe UI"/>
+              </a:defRPr>
+            </a:pPr>
             <a:r>
               <a:t>MSB7216: Deep Learning for Health Data</a:t>
             </a:r>
@@ -3177,46 +3201,62 @@
             <p:ph type="title"/>
           </p:nvPr>
         </p:nvSpPr>
+        <p:spPr>
+          <a:solidFill>
+            <a:srgbClr val="14325A"/>
+          </a:solidFill>
+        </p:spPr>
+        <p:txBody>
+          <a:bodyPr/>
+          <a:lstStyle/>
+          <a:p>
+            <a:pPr>
+              <a:defRPr b="1">
+                <a:solidFill>
+                  <a:srgbClr val="FFFFFF"/>
+                </a:solidFill>
+                <a:latin typeface="Segoe UI"/>
+              </a:defRPr>
+            </a:pPr>
+            <a:r>
+              <a:t>Results: Confusion Matrices</a:t>
+            </a:r>
+          </a:p>
+        </p:txBody>
+      </p:sp>
+      <p:sp>
+        <p:nvSpPr>
+          <p:cNvPr id="3" name="Content Placeholder 2"/>
+          <p:cNvSpPr>
+            <a:spLocks noGrp="1"/>
+          </p:cNvSpPr>
+          <p:nvPr>
+            <p:ph idx="1"/>
+          </p:nvPr>
+        </p:nvSpPr>
         <p:spPr/>
         <p:txBody>
           <a:bodyPr/>
           <a:lstStyle/>
-          <a:p>
-            <a:r>
-              <a:t>Results: Confusion Matrices</a:t>
-            </a:r>
-          </a:p>
-        </p:txBody>
-      </p:sp>
-      <p:sp>
-        <p:nvSpPr>
-          <p:cNvPr id="3" name="Content Placeholder 2"/>
-          <p:cNvSpPr>
-            <a:spLocks noGrp="1"/>
-          </p:cNvSpPr>
-          <p:nvPr>
-            <p:ph idx="1"/>
-          </p:nvPr>
-        </p:nvSpPr>
-        <p:spPr/>
-        <p:txBody>
-          <a:bodyPr/>
-          <a:lstStyle/>
           <a:p/>
           <a:p>
             <a:pPr>
-              <a:defRPr sz="1400"/>
-            </a:pPr>
-            <a:r>
-              <a:t>BiLSTM accurately maps minority classes.</a:t>
-            </a:r>
-          </a:p>
-          <a:p>
-            <a:pPr>
-              <a:defRPr sz="1400"/>
-            </a:pPr>
-            <a:r>
-              <a:t>CNN and DNABERT collapsed entirely (52.22% Subtype B baseline).</a:t>
+              <a:defRPr sz="1800">
+                <a:latin typeface="Segoe UI"/>
+              </a:defRPr>
+            </a:pPr>
+            <a:r>
+              <a:t>• BiLSTM accurately maps minority classes.</a:t>
+            </a:r>
+          </a:p>
+          <a:p>
+            <a:pPr>
+              <a:defRPr sz="1800">
+                <a:latin typeface="Segoe UI"/>
+              </a:defRPr>
+            </a:pPr>
+            <a:r>
+              <a:t>• CNN and DNABERT collapsed entirely (52.22% Subtype B baseline).</a:t>
             </a:r>
           </a:p>
         </p:txBody>
@@ -3273,38 +3313,52 @@
             <p:ph type="title"/>
           </p:nvPr>
         </p:nvSpPr>
+        <p:spPr>
+          <a:solidFill>
+            <a:srgbClr val="14325A"/>
+          </a:solidFill>
+        </p:spPr>
+        <p:txBody>
+          <a:bodyPr/>
+          <a:lstStyle/>
+          <a:p>
+            <a:pPr>
+              <a:defRPr b="1">
+                <a:solidFill>
+                  <a:srgbClr val="FFFFFF"/>
+                </a:solidFill>
+                <a:latin typeface="Segoe UI"/>
+              </a:defRPr>
+            </a:pPr>
+            <a:r>
+              <a:t>Results: ROC Curves</a:t>
+            </a:r>
+          </a:p>
+        </p:txBody>
+      </p:sp>
+      <p:sp>
+        <p:nvSpPr>
+          <p:cNvPr id="3" name="Content Placeholder 2"/>
+          <p:cNvSpPr>
+            <a:spLocks noGrp="1"/>
+          </p:cNvSpPr>
+          <p:nvPr>
+            <p:ph idx="1"/>
+          </p:nvPr>
+        </p:nvSpPr>
         <p:spPr/>
         <p:txBody>
           <a:bodyPr/>
           <a:lstStyle/>
-          <a:p>
-            <a:r>
-              <a:t>Results: ROC Curves</a:t>
-            </a:r>
-          </a:p>
-        </p:txBody>
-      </p:sp>
-      <p:sp>
-        <p:nvSpPr>
-          <p:cNvPr id="3" name="Content Placeholder 2"/>
-          <p:cNvSpPr>
-            <a:spLocks noGrp="1"/>
-          </p:cNvSpPr>
-          <p:nvPr>
-            <p:ph idx="1"/>
-          </p:nvPr>
-        </p:nvSpPr>
-        <p:spPr/>
-        <p:txBody>
-          <a:bodyPr/>
-          <a:lstStyle/>
           <a:p/>
           <a:p>
             <a:pPr>
-              <a:defRPr sz="1400"/>
-            </a:pPr>
-            <a:r>
-              <a:t>The Receiver Operating Characteristic confirms the BiLSTM's high true positive rate across all four classes.</a:t>
+              <a:defRPr sz="1800">
+                <a:latin typeface="Segoe UI"/>
+              </a:defRPr>
+            </a:pPr>
+            <a:r>
+              <a:t>• The Receiver Operating Characteristic confirms the BiLSTM's high true positive rate across all four classes.</a:t>
             </a:r>
           </a:p>
         </p:txBody>
@@ -3361,46 +3415,62 @@
             <p:ph type="title"/>
           </p:nvPr>
         </p:nvSpPr>
+        <p:spPr>
+          <a:solidFill>
+            <a:srgbClr val="14325A"/>
+          </a:solidFill>
+        </p:spPr>
+        <p:txBody>
+          <a:bodyPr/>
+          <a:lstStyle/>
+          <a:p>
+            <a:pPr>
+              <a:defRPr b="1">
+                <a:solidFill>
+                  <a:srgbClr val="FFFFFF"/>
+                </a:solidFill>
+                <a:latin typeface="Segoe UI"/>
+              </a:defRPr>
+            </a:pPr>
+            <a:r>
+              <a:t>Error Analysis</a:t>
+            </a:r>
+          </a:p>
+        </p:txBody>
+      </p:sp>
+      <p:sp>
+        <p:nvSpPr>
+          <p:cNvPr id="3" name="Content Placeholder 2"/>
+          <p:cNvSpPr>
+            <a:spLocks noGrp="1"/>
+          </p:cNvSpPr>
+          <p:nvPr>
+            <p:ph idx="1"/>
+          </p:nvPr>
+        </p:nvSpPr>
         <p:spPr/>
         <p:txBody>
           <a:bodyPr/>
           <a:lstStyle/>
-          <a:p>
-            <a:r>
-              <a:t>Error Analysis</a:t>
-            </a:r>
-          </a:p>
-        </p:txBody>
-      </p:sp>
-      <p:sp>
-        <p:nvSpPr>
-          <p:cNvPr id="3" name="Content Placeholder 2"/>
-          <p:cNvSpPr>
-            <a:spLocks noGrp="1"/>
-          </p:cNvSpPr>
-          <p:nvPr>
-            <p:ph idx="1"/>
-          </p:nvPr>
-        </p:nvSpPr>
-        <p:spPr/>
-        <p:txBody>
-          <a:bodyPr/>
-          <a:lstStyle/>
           <a:p/>
           <a:p>
             <a:pPr>
-              <a:defRPr sz="2000"/>
-            </a:pPr>
-            <a:r>
-              <a:t>Causes: CNNs and DNABERT collapsed due to geographic imbalance.</a:t>
-            </a:r>
-          </a:p>
-          <a:p>
-            <a:pPr>
-              <a:defRPr sz="2000"/>
-            </a:pPr>
-            <a:r>
-              <a:t>Implications: Saliency Maps show BiLSTMs rely on conserved regions. When 'viral drift' mutates these domains, confidence drops.</a:t>
+              <a:defRPr sz="1800">
+                <a:latin typeface="Segoe UI"/>
+              </a:defRPr>
+            </a:pPr>
+            <a:r>
+              <a:t>• Causes: CNNs and DNABERT collapsed due to geographic imbalance.</a:t>
+            </a:r>
+          </a:p>
+          <a:p>
+            <a:pPr>
+              <a:defRPr sz="1800">
+                <a:latin typeface="Segoe UI"/>
+              </a:defRPr>
+            </a:pPr>
+            <a:r>
+              <a:t>• Implications: Saliency Maps show BiLSTMs rely on conserved regions. When 'viral drift' mutates these domains, confidence drops.</a:t>
             </a:r>
           </a:p>
         </p:txBody>
@@ -3433,54 +3503,72 @@
             <p:ph type="title"/>
           </p:nvPr>
         </p:nvSpPr>
+        <p:spPr>
+          <a:solidFill>
+            <a:srgbClr val="14325A"/>
+          </a:solidFill>
+        </p:spPr>
+        <p:txBody>
+          <a:bodyPr/>
+          <a:lstStyle/>
+          <a:p>
+            <a:pPr>
+              <a:defRPr b="1">
+                <a:solidFill>
+                  <a:srgbClr val="FFFFFF"/>
+                </a:solidFill>
+                <a:latin typeface="Segoe UI"/>
+              </a:defRPr>
+            </a:pPr>
+            <a:r>
+              <a:t>Limitations &amp; Challenges</a:t>
+            </a:r>
+          </a:p>
+        </p:txBody>
+      </p:sp>
+      <p:sp>
+        <p:nvSpPr>
+          <p:cNvPr id="3" name="Content Placeholder 2"/>
+          <p:cNvSpPr>
+            <a:spLocks noGrp="1"/>
+          </p:cNvSpPr>
+          <p:nvPr>
+            <p:ph idx="1"/>
+          </p:nvPr>
+        </p:nvSpPr>
         <p:spPr/>
         <p:txBody>
           <a:bodyPr/>
           <a:lstStyle/>
-          <a:p>
-            <a:r>
-              <a:t>Limitations &amp; Challenges</a:t>
-            </a:r>
-          </a:p>
-        </p:txBody>
-      </p:sp>
-      <p:sp>
-        <p:nvSpPr>
-          <p:cNvPr id="3" name="Content Placeholder 2"/>
-          <p:cNvSpPr>
-            <a:spLocks noGrp="1"/>
-          </p:cNvSpPr>
-          <p:nvPr>
-            <p:ph idx="1"/>
-          </p:nvPr>
-        </p:nvSpPr>
-        <p:spPr/>
-        <p:txBody>
-          <a:bodyPr/>
-          <a:lstStyle/>
           <a:p/>
           <a:p>
             <a:pPr>
-              <a:defRPr sz="2000"/>
-            </a:pPr>
-            <a:r>
-              <a:t>1. Extreme Geographical Imbalance: Hard for spatial models (CNN) to overcome.</a:t>
-            </a:r>
-          </a:p>
-          <a:p>
-            <a:pPr>
-              <a:defRPr sz="2000"/>
-            </a:pPr>
-            <a:r>
-              <a:t>2. Computational Limits: VRAM restricted DNABERT's ability to learn 3000bp sequences.</a:t>
-            </a:r>
-          </a:p>
-          <a:p>
-            <a:pPr>
-              <a:defRPr sz="2000"/>
-            </a:pPr>
-            <a:r>
-              <a:t>3. Domain Gap: Human genome pre-training doesn't translate perfectly to viruses.</a:t>
+              <a:defRPr sz="1800">
+                <a:latin typeface="Segoe UI"/>
+              </a:defRPr>
+            </a:pPr>
+            <a:r>
+              <a:t>• 1. Extreme Geographical Imbalance: Hard for spatial models (CNN) to overcome.</a:t>
+            </a:r>
+          </a:p>
+          <a:p>
+            <a:pPr>
+              <a:defRPr sz="1800">
+                <a:latin typeface="Segoe UI"/>
+              </a:defRPr>
+            </a:pPr>
+            <a:r>
+              <a:t>• 2. Computational Limits: VRAM restricted DNABERT's ability to learn 3000bp sequences.</a:t>
+            </a:r>
+          </a:p>
+          <a:p>
+            <a:pPr>
+              <a:defRPr sz="1800">
+                <a:latin typeface="Segoe UI"/>
+              </a:defRPr>
+            </a:pPr>
+            <a:r>
+              <a:t>• 3. Domain Gap: Human genome pre-training doesn't translate perfectly to viruses.</a:t>
             </a:r>
           </a:p>
         </p:txBody>
@@ -3513,54 +3601,72 @@
             <p:ph type="title"/>
           </p:nvPr>
         </p:nvSpPr>
+        <p:spPr>
+          <a:solidFill>
+            <a:srgbClr val="14325A"/>
+          </a:solidFill>
+        </p:spPr>
+        <p:txBody>
+          <a:bodyPr/>
+          <a:lstStyle/>
+          <a:p>
+            <a:pPr>
+              <a:defRPr b="1">
+                <a:solidFill>
+                  <a:srgbClr val="FFFFFF"/>
+                </a:solidFill>
+                <a:latin typeface="Segoe UI"/>
+              </a:defRPr>
+            </a:pPr>
+            <a:r>
+              <a:t>Deployment Strategy</a:t>
+            </a:r>
+          </a:p>
+        </p:txBody>
+      </p:sp>
+      <p:sp>
+        <p:nvSpPr>
+          <p:cNvPr id="3" name="Content Placeholder 2"/>
+          <p:cNvSpPr>
+            <a:spLocks noGrp="1"/>
+          </p:cNvSpPr>
+          <p:nvPr>
+            <p:ph idx="1"/>
+          </p:nvPr>
+        </p:nvSpPr>
         <p:spPr/>
         <p:txBody>
           <a:bodyPr/>
           <a:lstStyle/>
-          <a:p>
-            <a:r>
-              <a:t>Deployment Strategy</a:t>
-            </a:r>
-          </a:p>
-        </p:txBody>
-      </p:sp>
-      <p:sp>
-        <p:nvSpPr>
-          <p:cNvPr id="3" name="Content Placeholder 2"/>
-          <p:cNvSpPr>
-            <a:spLocks noGrp="1"/>
-          </p:cNvSpPr>
-          <p:nvPr>
-            <p:ph idx="1"/>
-          </p:nvPr>
-        </p:nvSpPr>
-        <p:spPr/>
-        <p:txBody>
-          <a:bodyPr/>
-          <a:lstStyle/>
           <a:p/>
           <a:p>
             <a:pPr>
-              <a:defRPr sz="2000"/>
-            </a:pPr>
-            <a:r>
-              <a:t>Decoupled production deployment module.</a:t>
-            </a:r>
-          </a:p>
-          <a:p>
-            <a:pPr>
-              <a:defRPr sz="2000"/>
-            </a:pPr>
-            <a:r>
-              <a:t>Automatically loads the highest-performing architecture (BiLSTM).</a:t>
-            </a:r>
-          </a:p>
-          <a:p>
-            <a:pPr>
-              <a:defRPr sz="2000"/>
-            </a:pPr>
-            <a:r>
-              <a:t>Ready for real-time FASTA inference.</a:t>
+              <a:defRPr sz="1800">
+                <a:latin typeface="Segoe UI"/>
+              </a:defRPr>
+            </a:pPr>
+            <a:r>
+              <a:t>• Decoupled production deployment module.</a:t>
+            </a:r>
+          </a:p>
+          <a:p>
+            <a:pPr>
+              <a:defRPr sz="1800">
+                <a:latin typeface="Segoe UI"/>
+              </a:defRPr>
+            </a:pPr>
+            <a:r>
+              <a:t>• Automatically loads the highest-performing architecture (BiLSTM).</a:t>
+            </a:r>
+          </a:p>
+          <a:p>
+            <a:pPr>
+              <a:defRPr sz="1800">
+                <a:latin typeface="Segoe UI"/>
+              </a:defRPr>
+            </a:pPr>
+            <a:r>
+              <a:t>• Ready for real-time FASTA inference.</a:t>
             </a:r>
           </a:p>
         </p:txBody>
@@ -3593,46 +3699,62 @@
             <p:ph type="title"/>
           </p:nvPr>
         </p:nvSpPr>
+        <p:spPr>
+          <a:solidFill>
+            <a:srgbClr val="14325A"/>
+          </a:solidFill>
+        </p:spPr>
+        <p:txBody>
+          <a:bodyPr/>
+          <a:lstStyle/>
+          <a:p>
+            <a:pPr>
+              <a:defRPr b="1">
+                <a:solidFill>
+                  <a:srgbClr val="FFFFFF"/>
+                </a:solidFill>
+                <a:latin typeface="Segoe UI"/>
+              </a:defRPr>
+            </a:pPr>
+            <a:r>
+              <a:t>Conclusion &amp; Future Work</a:t>
+            </a:r>
+          </a:p>
+        </p:txBody>
+      </p:sp>
+      <p:sp>
+        <p:nvSpPr>
+          <p:cNvPr id="3" name="Content Placeholder 2"/>
+          <p:cNvSpPr>
+            <a:spLocks noGrp="1"/>
+          </p:cNvSpPr>
+          <p:nvPr>
+            <p:ph idx="1"/>
+          </p:nvPr>
+        </p:nvSpPr>
         <p:spPr/>
         <p:txBody>
           <a:bodyPr/>
           <a:lstStyle/>
-          <a:p>
-            <a:r>
-              <a:t>Conclusion &amp; Future Work</a:t>
-            </a:r>
-          </a:p>
-        </p:txBody>
-      </p:sp>
-      <p:sp>
-        <p:nvSpPr>
-          <p:cNvPr id="3" name="Content Placeholder 2"/>
-          <p:cNvSpPr>
-            <a:spLocks noGrp="1"/>
-          </p:cNvSpPr>
-          <p:nvPr>
-            <p:ph idx="1"/>
-          </p:nvPr>
-        </p:nvSpPr>
-        <p:spPr/>
-        <p:txBody>
-          <a:bodyPr/>
-          <a:lstStyle/>
           <a:p/>
           <a:p>
             <a:pPr>
-              <a:defRPr sz="2000"/>
-            </a:pPr>
-            <a:r>
-              <a:t>Conclusion: Alignment-free Deep Learning (BiLSTM) handles viral genomic imbalances far better than CNNs, achieving 94.73% accuracy.</a:t>
-            </a:r>
-          </a:p>
-          <a:p>
-            <a:pPr>
-              <a:defRPr sz="2000"/>
-            </a:pPr>
-            <a:r>
-              <a:t>Future Work: Expand to Circulating Recombinant Forms (CRFs) and launch via FastAPI.</a:t>
+              <a:defRPr sz="1800">
+                <a:latin typeface="Segoe UI"/>
+              </a:defRPr>
+            </a:pPr>
+            <a:r>
+              <a:t>• Conclusion: Alignment-free Deep Learning (BiLSTM) handles viral genomic imbalances far better than CNNs, achieving 94.73% accuracy.</a:t>
+            </a:r>
+          </a:p>
+          <a:p>
+            <a:pPr>
+              <a:defRPr sz="1800">
+                <a:latin typeface="Segoe UI"/>
+              </a:defRPr>
+            </a:pPr>
+            <a:r>
+              <a:t>• Future Work: Expand to Circulating Recombinant Forms (CRFs) and launch via FastAPI.</a:t>
             </a:r>
           </a:p>
         </p:txBody>
@@ -3665,70 +3787,92 @@
             <p:ph type="title"/>
           </p:nvPr>
         </p:nvSpPr>
+        <p:spPr>
+          <a:solidFill>
+            <a:srgbClr val="14325A"/>
+          </a:solidFill>
+        </p:spPr>
+        <p:txBody>
+          <a:bodyPr/>
+          <a:lstStyle/>
+          <a:p>
+            <a:pPr>
+              <a:defRPr b="1">
+                <a:solidFill>
+                  <a:srgbClr val="FFFFFF"/>
+                </a:solidFill>
+                <a:latin typeface="Segoe UI"/>
+              </a:defRPr>
+            </a:pPr>
+            <a:r>
+              <a:t>Abstract &amp; Overview</a:t>
+            </a:r>
+          </a:p>
+        </p:txBody>
+      </p:sp>
+      <p:sp>
+        <p:nvSpPr>
+          <p:cNvPr id="3" name="Content Placeholder 2"/>
+          <p:cNvSpPr>
+            <a:spLocks noGrp="1"/>
+          </p:cNvSpPr>
+          <p:nvPr>
+            <p:ph idx="1"/>
+          </p:nvPr>
+        </p:nvSpPr>
         <p:spPr/>
         <p:txBody>
           <a:bodyPr/>
           <a:lstStyle/>
-          <a:p>
-            <a:r>
-              <a:t>Abstract &amp; Overview</a:t>
-            </a:r>
-          </a:p>
-        </p:txBody>
-      </p:sp>
-      <p:sp>
-        <p:nvSpPr>
-          <p:cNvPr id="3" name="Content Placeholder 2"/>
-          <p:cNvSpPr>
-            <a:spLocks noGrp="1"/>
-          </p:cNvSpPr>
-          <p:nvPr>
-            <p:ph idx="1"/>
-          </p:nvPr>
-        </p:nvSpPr>
-        <p:spPr/>
-        <p:txBody>
-          <a:bodyPr/>
-          <a:lstStyle/>
           <a:p/>
           <a:p>
             <a:pPr>
-              <a:defRPr sz="2000"/>
-            </a:pPr>
-            <a:r>
-              <a:t>Background: HIV-1 subtyping is essential for guiding antiretroviral therapy and tracking epidemiological spread.</a:t>
-            </a:r>
-          </a:p>
-          <a:p>
-            <a:pPr>
-              <a:defRPr sz="2000"/>
-            </a:pPr>
-            <a:r>
-              <a:t>Previous Work: Existing tools heavily rely on computationally expensive Multiple Sequence Alignment (MSA) or k-mer counting.</a:t>
-            </a:r>
-          </a:p>
-          <a:p>
-            <a:pPr>
-              <a:defRPr sz="2000"/>
-            </a:pPr>
-            <a:r>
-              <a:t>Problem Statement: MSA struggles with hypermutations, and genomic databases suffer from severe geographical class imbalance.</a:t>
-            </a:r>
-          </a:p>
-          <a:p>
-            <a:pPr>
-              <a:defRPr sz="2000"/>
-            </a:pPr>
-            <a:r>
-              <a:t>Objective: To develop an automated, alignment-free Deep Learning classifier to categorize raw nucleotide sequences into Subtypes A, B, C, and D.</a:t>
-            </a:r>
-          </a:p>
-          <a:p>
-            <a:pPr>
-              <a:defRPr sz="2000"/>
-            </a:pPr>
-            <a:r>
-              <a:t>Significance: Eliminating the MSA bottleneck enables faster, more scalable, and highly accurate subtyping for clinical deployment.</a:t>
+              <a:defRPr sz="1800">
+                <a:latin typeface="Segoe UI"/>
+              </a:defRPr>
+            </a:pPr>
+            <a:r>
+              <a:t>• Background: HIV-1 subtyping is essential for guiding antiretroviral therapy and tracking epidemiological spread.</a:t>
+            </a:r>
+          </a:p>
+          <a:p>
+            <a:pPr>
+              <a:defRPr sz="1800">
+                <a:latin typeface="Segoe UI"/>
+              </a:defRPr>
+            </a:pPr>
+            <a:r>
+              <a:t>• Previous Work: Existing tools heavily rely on computationally expensive Multiple Sequence Alignment (MSA) or k-mer counting.</a:t>
+            </a:r>
+          </a:p>
+          <a:p>
+            <a:pPr>
+              <a:defRPr sz="1800">
+                <a:latin typeface="Segoe UI"/>
+              </a:defRPr>
+            </a:pPr>
+            <a:r>
+              <a:t>• Problem Statement: MSA struggles with hypermutations, and genomic databases suffer from severe geographical class imbalance.</a:t>
+            </a:r>
+          </a:p>
+          <a:p>
+            <a:pPr>
+              <a:defRPr sz="1800">
+                <a:latin typeface="Segoe UI"/>
+              </a:defRPr>
+            </a:pPr>
+            <a:r>
+              <a:t>• Objective: To develop an automated, alignment-free Deep Learning classifier to categorize raw nucleotide sequences into Subtypes A, B, C, and D.</a:t>
+            </a:r>
+          </a:p>
+          <a:p>
+            <a:pPr>
+              <a:defRPr sz="1800">
+                <a:latin typeface="Segoe UI"/>
+              </a:defRPr>
+            </a:pPr>
+            <a:r>
+              <a:t>• Significance: Eliminating the MSA bottleneck enables faster, more scalable, and highly accurate subtyping for clinical deployment.</a:t>
             </a:r>
           </a:p>
         </p:txBody>
@@ -3761,70 +3905,92 @@
             <p:ph type="title"/>
           </p:nvPr>
         </p:nvSpPr>
+        <p:spPr>
+          <a:solidFill>
+            <a:srgbClr val="14325A"/>
+          </a:solidFill>
+        </p:spPr>
+        <p:txBody>
+          <a:bodyPr/>
+          <a:lstStyle/>
+          <a:p>
+            <a:pPr>
+              <a:defRPr b="1">
+                <a:solidFill>
+                  <a:srgbClr val="FFFFFF"/>
+                </a:solidFill>
+                <a:latin typeface="Segoe UI"/>
+              </a:defRPr>
+            </a:pPr>
+            <a:r>
+              <a:t>Data Acquisition (Kameris Experiment)</a:t>
+            </a:r>
+          </a:p>
+        </p:txBody>
+      </p:sp>
+      <p:sp>
+        <p:nvSpPr>
+          <p:cNvPr id="3" name="Content Placeholder 2"/>
+          <p:cNvSpPr>
+            <a:spLocks noGrp="1"/>
+          </p:cNvSpPr>
+          <p:nvPr>
+            <p:ph idx="1"/>
+          </p:nvPr>
+        </p:nvSpPr>
         <p:spPr/>
         <p:txBody>
           <a:bodyPr/>
           <a:lstStyle/>
-          <a:p>
-            <a:r>
-              <a:t>Data Acquisition (Kameris Experiment)</a:t>
-            </a:r>
-          </a:p>
-        </p:txBody>
-      </p:sp>
-      <p:sp>
-        <p:nvSpPr>
-          <p:cNvPr id="3" name="Content Placeholder 2"/>
-          <p:cNvSpPr>
-            <a:spLocks noGrp="1"/>
-          </p:cNvSpPr>
-          <p:nvPr>
-            <p:ph idx="1"/>
-          </p:nvPr>
-        </p:nvSpPr>
-        <p:spPr/>
-        <p:txBody>
-          <a:bodyPr/>
-          <a:lstStyle/>
           <a:p/>
           <a:p>
             <a:pPr>
-              <a:defRPr sz="2000"/>
-            </a:pPr>
-            <a:r>
-              <a:t>Data was acquired by parsing 9,270 HIV-1 pol gene accessions utilized in the Kameris et al. experiment.</a:t>
-            </a:r>
-          </a:p>
-          <a:p>
-            <a:pPr>
-              <a:defRPr sz="2000"/>
-            </a:pPr>
-            <a:r>
-              <a:t>A JSON file was pulled from the Kameris GitHub repository to extract specific LANL sequence IDs.</a:t>
-            </a:r>
-          </a:p>
-          <a:p>
-            <a:pPr>
-              <a:defRPr sz="2000"/>
-            </a:pPr>
-            <a:r>
-              <a:t>These IDs were fed into the LANL HIV Sequence Database to batch download the raw FASTA sequences.</a:t>
-            </a:r>
-          </a:p>
-          <a:p>
-            <a:pPr>
-              <a:defRPr sz="2000"/>
-            </a:pPr>
-            <a:r>
-              <a:t>Sequences were then strictly filtered to our 4 target classes: Subtypes A, B, C, and D.</a:t>
-            </a:r>
-          </a:p>
-          <a:p>
-            <a:pPr>
-              <a:defRPr sz="2000"/>
-            </a:pPr>
-            <a:r>
-              <a:t>Severe Bias: Subtype B heavily dominates the final dataset (52.2%).</a:t>
+              <a:defRPr sz="1800">
+                <a:latin typeface="Segoe UI"/>
+              </a:defRPr>
+            </a:pPr>
+            <a:r>
+              <a:t>• Data was acquired by parsing 9,270 HIV-1 pol gene accessions utilized in the Kameris et al. experiment.</a:t>
+            </a:r>
+          </a:p>
+          <a:p>
+            <a:pPr>
+              <a:defRPr sz="1800">
+                <a:latin typeface="Segoe UI"/>
+              </a:defRPr>
+            </a:pPr>
+            <a:r>
+              <a:t>• A JSON file was pulled from the Kameris GitHub repository to extract specific LANL sequence IDs.</a:t>
+            </a:r>
+          </a:p>
+          <a:p>
+            <a:pPr>
+              <a:defRPr sz="1800">
+                <a:latin typeface="Segoe UI"/>
+              </a:defRPr>
+            </a:pPr>
+            <a:r>
+              <a:t>• These IDs were fed into the LANL HIV Sequence Database to batch download the raw FASTA sequences.</a:t>
+            </a:r>
+          </a:p>
+          <a:p>
+            <a:pPr>
+              <a:defRPr sz="1800">
+                <a:latin typeface="Segoe UI"/>
+              </a:defRPr>
+            </a:pPr>
+            <a:r>
+              <a:t>• Sequences were then strictly filtered to our 4 target classes: Subtypes A, B, C, and D.</a:t>
+            </a:r>
+          </a:p>
+          <a:p>
+            <a:pPr>
+              <a:defRPr sz="1800">
+                <a:latin typeface="Segoe UI"/>
+              </a:defRPr>
+            </a:pPr>
+            <a:r>
+              <a:t>• Severe Bias: Subtype B heavily dominates the final dataset (52.2%).</a:t>
             </a:r>
           </a:p>
         </p:txBody>
@@ -3857,11 +4023,23 @@
             <p:ph type="title"/>
           </p:nvPr>
         </p:nvSpPr>
-        <p:spPr/>
-        <p:txBody>
-          <a:bodyPr/>
-          <a:lstStyle/>
-          <a:p>
+        <p:spPr>
+          <a:solidFill>
+            <a:srgbClr val="14325A"/>
+          </a:solidFill>
+        </p:spPr>
+        <p:txBody>
+          <a:bodyPr/>
+          <a:lstStyle/>
+          <a:p>
+            <a:pPr>
+              <a:defRPr b="1">
+                <a:solidFill>
+                  <a:srgbClr val="FFFFFF"/>
+                </a:solidFill>
+                <a:latin typeface="Segoe UI"/>
+              </a:defRPr>
+            </a:pPr>
             <a:r>
               <a:t>Methodology: Processing &amp; Encoding</a:t>
             </a:r>
@@ -4137,11 +4315,23 @@
             <p:ph type="title"/>
           </p:nvPr>
         </p:nvSpPr>
-        <p:spPr/>
-        <p:txBody>
-          <a:bodyPr/>
-          <a:lstStyle/>
-          <a:p>
+        <p:spPr>
+          <a:solidFill>
+            <a:srgbClr val="14325A"/>
+          </a:solidFill>
+        </p:spPr>
+        <p:txBody>
+          <a:bodyPr/>
+          <a:lstStyle/>
+          <a:p>
+            <a:pPr>
+              <a:defRPr b="1">
+                <a:solidFill>
+                  <a:srgbClr val="FFFFFF"/>
+                </a:solidFill>
+                <a:latin typeface="Segoe UI"/>
+              </a:defRPr>
+            </a:pPr>
             <a:r>
               <a:t>Methodology: Data Splitting &amp; Class Balancing</a:t>
             </a:r>
@@ -4257,54 +4447,72 @@
             <p:ph type="title"/>
           </p:nvPr>
         </p:nvSpPr>
+        <p:spPr>
+          <a:solidFill>
+            <a:srgbClr val="14325A"/>
+          </a:solidFill>
+        </p:spPr>
+        <p:txBody>
+          <a:bodyPr/>
+          <a:lstStyle/>
+          <a:p>
+            <a:pPr>
+              <a:defRPr b="1">
+                <a:solidFill>
+                  <a:srgbClr val="FFFFFF"/>
+                </a:solidFill>
+                <a:latin typeface="Segoe UI"/>
+              </a:defRPr>
+            </a:pPr>
+            <a:r>
+              <a:t>Methodology: Architectures</a:t>
+            </a:r>
+          </a:p>
+        </p:txBody>
+      </p:sp>
+      <p:sp>
+        <p:nvSpPr>
+          <p:cNvPr id="3" name="Content Placeholder 2"/>
+          <p:cNvSpPr>
+            <a:spLocks noGrp="1"/>
+          </p:cNvSpPr>
+          <p:nvPr>
+            <p:ph idx="1"/>
+          </p:nvPr>
+        </p:nvSpPr>
         <p:spPr/>
         <p:txBody>
           <a:bodyPr/>
           <a:lstStyle/>
-          <a:p>
-            <a:r>
-              <a:t>Methodology: Architectures</a:t>
-            </a:r>
-          </a:p>
-        </p:txBody>
-      </p:sp>
-      <p:sp>
-        <p:nvSpPr>
-          <p:cNvPr id="3" name="Content Placeholder 2"/>
-          <p:cNvSpPr>
-            <a:spLocks noGrp="1"/>
-          </p:cNvSpPr>
-          <p:nvPr>
-            <p:ph idx="1"/>
-          </p:nvPr>
-        </p:nvSpPr>
-        <p:spPr/>
-        <p:txBody>
-          <a:bodyPr/>
-          <a:lstStyle/>
           <a:p/>
           <a:p>
             <a:pPr>
-              <a:defRPr sz="2000"/>
-            </a:pPr>
-            <a:r>
-              <a:t>1. Baseline MLP (73.8k Params): GlobalAvgPool -&gt; Dense(16) -&gt; Classifier.</a:t>
-            </a:r>
-          </a:p>
-          <a:p>
-            <a:pPr>
-              <a:defRPr sz="2000"/>
-            </a:pPr>
-            <a:r>
-              <a:t>2. 1D-CNN (200k Params): 4 Conv1D layers (filters: 32 to 128) alternating with MaxPool &amp; Dropout (0.5).</a:t>
-            </a:r>
-          </a:p>
-          <a:p>
-            <a:pPr>
-              <a:defRPr sz="2000"/>
-            </a:pPr>
-            <a:r>
-              <a:t>3. BiLSTM (2.1M Params): 128-dim Embedding -&gt; 2-layer Bidirectional LSTM (256 hidden) -&gt; Dense(128).</a:t>
+              <a:defRPr sz="1800">
+                <a:latin typeface="Segoe UI"/>
+              </a:defRPr>
+            </a:pPr>
+            <a:r>
+              <a:t>• 1. Baseline MLP (73.8k Params): GlobalAvgPool -&gt; Dense(16) -&gt; Classifier.</a:t>
+            </a:r>
+          </a:p>
+          <a:p>
+            <a:pPr>
+              <a:defRPr sz="1800">
+                <a:latin typeface="Segoe UI"/>
+              </a:defRPr>
+            </a:pPr>
+            <a:r>
+              <a:t>• 2. 1D-CNN (200k Params): 4 Conv1D layers (filters: 32 to 128) alternating with MaxPool &amp; Dropout (0.5).</a:t>
+            </a:r>
+          </a:p>
+          <a:p>
+            <a:pPr>
+              <a:defRPr sz="1800">
+                <a:latin typeface="Segoe UI"/>
+              </a:defRPr>
+            </a:pPr>
+            <a:r>
+              <a:t>• 3. BiLSTM (2.1M Params): 128-dim Embedding -&gt; 2-layer Bidirectional LSTM (256 hidden) -&gt; Dense(128).</a:t>
             </a:r>
           </a:p>
         </p:txBody>
@@ -4337,54 +4545,72 @@
             <p:ph type="title"/>
           </p:nvPr>
         </p:nvSpPr>
+        <p:spPr>
+          <a:solidFill>
+            <a:srgbClr val="14325A"/>
+          </a:solidFill>
+        </p:spPr>
+        <p:txBody>
+          <a:bodyPr/>
+          <a:lstStyle/>
+          <a:p>
+            <a:pPr>
+              <a:defRPr b="1">
+                <a:solidFill>
+                  <a:srgbClr val="FFFFFF"/>
+                </a:solidFill>
+                <a:latin typeface="Segoe UI"/>
+              </a:defRPr>
+            </a:pPr>
+            <a:r>
+              <a:t>Methodology: Transfer Learning</a:t>
+            </a:r>
+          </a:p>
+        </p:txBody>
+      </p:sp>
+      <p:sp>
+        <p:nvSpPr>
+          <p:cNvPr id="3" name="Content Placeholder 2"/>
+          <p:cNvSpPr>
+            <a:spLocks noGrp="1"/>
+          </p:cNvSpPr>
+          <p:nvPr>
+            <p:ph idx="1"/>
+          </p:nvPr>
+        </p:nvSpPr>
         <p:spPr/>
         <p:txBody>
           <a:bodyPr/>
           <a:lstStyle/>
-          <a:p>
-            <a:r>
-              <a:t>Methodology: Transfer Learning</a:t>
-            </a:r>
-          </a:p>
-        </p:txBody>
-      </p:sp>
-      <p:sp>
-        <p:nvSpPr>
-          <p:cNvPr id="3" name="Content Placeholder 2"/>
-          <p:cNvSpPr>
-            <a:spLocks noGrp="1"/>
-          </p:cNvSpPr>
-          <p:nvPr>
-            <p:ph idx="1"/>
-          </p:nvPr>
-        </p:nvSpPr>
-        <p:spPr/>
-        <p:txBody>
-          <a:bodyPr/>
-          <a:lstStyle/>
           <a:p/>
           <a:p>
             <a:pPr>
-              <a:defRPr sz="1400"/>
-            </a:pPr>
-            <a:r>
-              <a:t>Exploratory phase utilizing DNABERT.</a:t>
-            </a:r>
-          </a:p>
-          <a:p>
-            <a:pPr>
-              <a:defRPr sz="1400"/>
-            </a:pPr>
-            <a:r>
-              <a:t>Pre-trained on the human genome via Masked Language Modeling.</a:t>
-            </a:r>
-          </a:p>
-          <a:p>
-            <a:pPr>
-              <a:defRPr sz="1400"/>
-            </a:pPr>
-            <a:r>
-              <a:t>Classification head fine-tuned to test cross-domain transfer learning to viral genomes.</a:t>
+              <a:defRPr sz="1800">
+                <a:latin typeface="Segoe UI"/>
+              </a:defRPr>
+            </a:pPr>
+            <a:r>
+              <a:t>• Exploratory phase utilizing DNABERT.</a:t>
+            </a:r>
+          </a:p>
+          <a:p>
+            <a:pPr>
+              <a:defRPr sz="1800">
+                <a:latin typeface="Segoe UI"/>
+              </a:defRPr>
+            </a:pPr>
+            <a:r>
+              <a:t>• Pre-trained on the human genome via Masked Language Modeling.</a:t>
+            </a:r>
+          </a:p>
+          <a:p>
+            <a:pPr>
+              <a:defRPr sz="1800">
+                <a:latin typeface="Segoe UI"/>
+              </a:defRPr>
+            </a:pPr>
+            <a:r>
+              <a:t>• Classification head fine-tuned to test cross-domain transfer learning to viral genomes.</a:t>
             </a:r>
           </a:p>
         </p:txBody>
@@ -4441,46 +4667,62 @@
             <p:ph type="title"/>
           </p:nvPr>
         </p:nvSpPr>
+        <p:spPr>
+          <a:solidFill>
+            <a:srgbClr val="14325A"/>
+          </a:solidFill>
+        </p:spPr>
+        <p:txBody>
+          <a:bodyPr/>
+          <a:lstStyle/>
+          <a:p>
+            <a:pPr>
+              <a:defRPr b="1">
+                <a:solidFill>
+                  <a:srgbClr val="FFFFFF"/>
+                </a:solidFill>
+                <a:latin typeface="Segoe UI"/>
+              </a:defRPr>
+            </a:pPr>
+            <a:r>
+              <a:t>Methodology: Explainability</a:t>
+            </a:r>
+          </a:p>
+        </p:txBody>
+      </p:sp>
+      <p:sp>
+        <p:nvSpPr>
+          <p:cNvPr id="3" name="Content Placeholder 2"/>
+          <p:cNvSpPr>
+            <a:spLocks noGrp="1"/>
+          </p:cNvSpPr>
+          <p:nvPr>
+            <p:ph idx="1"/>
+          </p:nvPr>
+        </p:nvSpPr>
         <p:spPr/>
         <p:txBody>
           <a:bodyPr/>
           <a:lstStyle/>
-          <a:p>
-            <a:r>
-              <a:t>Methodology: Explainability</a:t>
-            </a:r>
-          </a:p>
-        </p:txBody>
-      </p:sp>
-      <p:sp>
-        <p:nvSpPr>
-          <p:cNvPr id="3" name="Content Placeholder 2"/>
-          <p:cNvSpPr>
-            <a:spLocks noGrp="1"/>
-          </p:cNvSpPr>
-          <p:nvPr>
-            <p:ph idx="1"/>
-          </p:nvPr>
-        </p:nvSpPr>
-        <p:spPr/>
-        <p:txBody>
-          <a:bodyPr/>
-          <a:lstStyle/>
           <a:p/>
           <a:p>
             <a:pPr>
-              <a:defRPr sz="1400"/>
-            </a:pPr>
-            <a:r>
-              <a:t>Universal Saliency Map using Input-Gradient Attention.</a:t>
-            </a:r>
-          </a:p>
-          <a:p>
-            <a:pPr>
-              <a:defRPr sz="1400"/>
-            </a:pPr>
-            <a:r>
-              <a:t>Highlights the exact nucleotide regions driving the BiLSTM's classifications.</a:t>
+              <a:defRPr sz="1800">
+                <a:latin typeface="Segoe UI"/>
+              </a:defRPr>
+            </a:pPr>
+            <a:r>
+              <a:t>• Universal Saliency Map using Input-Gradient Attention.</a:t>
+            </a:r>
+          </a:p>
+          <a:p>
+            <a:pPr>
+              <a:defRPr sz="1800">
+                <a:latin typeface="Segoe UI"/>
+              </a:defRPr>
+            </a:pPr>
+            <a:r>
+              <a:t>• Highlights the exact nucleotide regions driving the BiLSTM's classifications.</a:t>
             </a:r>
           </a:p>
         </p:txBody>
@@ -4513,11 +4755,23 @@
             <p:ph type="title"/>
           </p:nvPr>
         </p:nvSpPr>
-        <p:spPr/>
-        <p:txBody>
-          <a:bodyPr/>
-          <a:lstStyle/>
-          <a:p>
+        <p:spPr>
+          <a:solidFill>
+            <a:srgbClr val="14325A"/>
+          </a:solidFill>
+        </p:spPr>
+        <p:txBody>
+          <a:bodyPr/>
+          <a:lstStyle/>
+          <a:p>
+            <a:pPr>
+              <a:defRPr b="1">
+                <a:solidFill>
+                  <a:srgbClr val="FFFFFF"/>
+                </a:solidFill>
+                <a:latin typeface="Segoe UI"/>
+              </a:defRPr>
+            </a:pPr>
             <a:r>
               <a:t>Results: Model Comparison</a:t>
             </a:r>

</xml_diff>

<commit_message>
Update Title slide to light theme with decision boundary illustration and improved spacing
</commit_message>
<xml_diff>
--- a/reports/presentation.pptx
+++ b/reports/presentation.pptx
@@ -3112,12 +3112,23 @@
             <p:ph type="ctrTitle"/>
           </p:nvPr>
         </p:nvSpPr>
-        <p:spPr/>
-        <p:txBody>
-          <a:bodyPr/>
-          <a:lstStyle/>
-          <a:p>
-            <a:pPr>
+        <p:spPr>
+          <a:xfrm>
+            <a:off x="457200" y="0"/>
+            <a:ext cx="4572000" cy="0"/>
+          </a:xfrm>
+          <a:solidFill>
+            <a:srgbClr val="F0F5FA"/>
+          </a:solidFill>
+        </p:spPr>
+        <p:txBody>
+          <a:bodyPr/>
+          <a:lstStyle/>
+          <a:p>
+            <a:pPr>
+              <a:lnSpc>
+                <a:spcPct val="120000"/>
+              </a:lnSpc>
               <a:defRPr b="1">
                 <a:solidFill>
                   <a:srgbClr val="14325A"/>
@@ -3141,12 +3152,20 @@
             <p:ph type="subTitle" idx="1"/>
           </p:nvPr>
         </p:nvSpPr>
-        <p:spPr/>
-        <p:txBody>
-          <a:bodyPr/>
-          <a:lstStyle/>
-          <a:p>
-            <a:pPr>
+        <p:spPr>
+          <a:xfrm>
+            <a:off x="457200" y="0"/>
+            <a:ext cx="4572000" cy="0"/>
+          </a:xfrm>
+        </p:spPr>
+        <p:txBody>
+          <a:bodyPr/>
+          <a:lstStyle/>
+          <a:p>
+            <a:pPr>
+              <a:lnSpc>
+                <a:spcPct val="120000"/>
+              </a:lnSpc>
               <a:defRPr>
                 <a:solidFill>
                   <a:srgbClr val="505050"/>
@@ -3160,6 +3179,9 @@
           </a:p>
           <a:p>
             <a:pPr>
+              <a:lnSpc>
+                <a:spcPct val="120000"/>
+              </a:lnSpc>
               <a:defRPr>
                 <a:solidFill>
                   <a:srgbClr val="505050"/>
@@ -3173,6 +3195,30 @@
           </a:p>
         </p:txBody>
       </p:sp>
+      <p:pic>
+        <p:nvPicPr>
+          <p:cNvPr id="4" name="Picture 3" descr="mlp_decision_boundaries.png"/>
+          <p:cNvPicPr>
+            <a:picLocks noChangeAspect="1"/>
+          </p:cNvPicPr>
+          <p:nvPr/>
+        </p:nvPicPr>
+        <p:blipFill>
+          <a:blip r:embed="rId2"/>
+          <a:stretch>
+            <a:fillRect/>
+          </a:stretch>
+        </p:blipFill>
+        <p:spPr>
+          <a:xfrm>
+            <a:off x="5029200" y="914400"/>
+            <a:ext cx="3657600" cy="2987644"/>
+          </a:xfrm>
+          <a:prstGeom prst="rect">
+            <a:avLst/>
+          </a:prstGeom>
+        </p:spPr>
+      </p:pic>
     </p:spTree>
   </p:cSld>
   <p:clrMapOvr>

</xml_diff>